<commit_message>
Se sube proyecto y se actualiza presentacion
Se sube proyecto y se actualiza presentacion debido a que habian incoherencias.
</commit_message>
<xml_diff>
--- a/Fase 2/Evidencias Proyecto/Presentación Proyecto Fase 2.pptx
+++ b/Fase 2/Evidencias Proyecto/Presentación Proyecto Fase 2.pptx
@@ -64,6 +64,7 @@
       <p:font typeface="Open Sans" panose="020B0606030504020204" pitchFamily="34" charset="0"/>
       <p:regular r:id="rId45"/>
       <p:bold r:id="rId46"/>
+      <p:boldItalic r:id="rId47"/>
     </p:embeddedFont>
   </p:embeddedFontLst>
   <p:defaultTextStyle>
@@ -296,8 +297,11 @@
     </a:lvl9pPr>
   </p:defaultTextStyle>
   <p:extLst>
+    <p:ext uri="{EFAFB233-063F-42B5-8137-9DF3F51BA10A}">
+      <p15:sldGuideLst xmlns:p15="http://schemas.microsoft.com/office/powerpoint/2012/main"/>
+    </p:ext>
     <p:ext uri="GoogleSlidesCustomDataVersion2">
-      <go:slidesCustomData xmlns:go="http://customooxmlschemas.google.com/" xmlns:ahyp="http://schemas.microsoft.com/office/drawing/2018/hyperlinkcolor" xmlns:p15="http://schemas.microsoft.com/office/powerpoint/2012/main" xmlns:p14="http://schemas.microsoft.com/office/powerpoint/2010/main" xmlns:com="http://schemas.openxmlformats.org/drawingml/2006/compatibility" xmlns:pvml="urn:schemas-microsoft-com:office:powerpoint" xmlns:v="urn:schemas-microsoft-com:vml" xmlns:o="urn:schemas-microsoft-com:office:office" xmlns:dgm="http://schemas.openxmlformats.org/drawingml/2006/diagram" xmlns:c="http://schemas.openxmlformats.org/drawingml/2006/chart" xmlns:mv="urn:schemas-microsoft-com:mac:vml" xmlns:mc="http://schemas.openxmlformats.org/markup-compatibility/2006" xmlns="" r:id="rId52" roundtripDataSignature="AMtx7mgWvjnKcBD88fzBwwh3cIxC7UmYFQ=="/>
+      <go:slidesCustomData xmlns="" xmlns:mc="http://schemas.openxmlformats.org/markup-compatibility/2006" xmlns:mv="urn:schemas-microsoft-com:mac:vml" xmlns:c="http://schemas.openxmlformats.org/drawingml/2006/chart" xmlns:dgm="http://schemas.openxmlformats.org/drawingml/2006/diagram" xmlns:o="urn:schemas-microsoft-com:office:office" xmlns:v="urn:schemas-microsoft-com:vml" xmlns:pvml="urn:schemas-microsoft-com:office:powerpoint" xmlns:com="http://schemas.openxmlformats.org/drawingml/2006/compatibility" xmlns:p14="http://schemas.microsoft.com/office/powerpoint/2010/main" xmlns:p15="http://schemas.microsoft.com/office/powerpoint/2012/main" xmlns:ahyp="http://schemas.microsoft.com/office/drawing/2018/hyperlinkcolor" xmlns:go="http://customooxmlschemas.google.com/" r:id="rId52" roundtripDataSignature="AMtx7mgWvjnKcBD88fzBwwh3cIxC7UmYFQ=="/>
     </p:ext>
   </p:extLst>
 </p:presentation>
@@ -34849,13 +34853,13 @@
   <p:clrMapOvr>
     <a:masterClrMapping/>
   </p:clrMapOvr>
-  <mc:AlternateContent xmlns:mc="http://schemas.openxmlformats.org/markup-compatibility/2006">
-    <mc:Choice xmlns:p159="http://schemas.microsoft.com/office/powerpoint/2015/09/main" Requires="p159">
+  <mc:AlternateContent xmlns:mc="http://schemas.openxmlformats.org/markup-compatibility/2006" xmlns:p159="http://schemas.microsoft.com/office/powerpoint/2015/09/main">
+    <mc:Choice Requires="p159">
       <p:transition xmlns:p14="http://schemas.microsoft.com/office/powerpoint/2010/main" spd="slow" p14:dur="2000">
         <p159:morph option="byObject"/>
       </p:transition>
     </mc:Choice>
-    <mc:Fallback>
+    <mc:Fallback xmlns="">
       <p:transition spd="slow">
         <p:fade/>
       </p:transition>
@@ -36767,13 +36771,13 @@
   <p:clrMapOvr>
     <a:masterClrMapping/>
   </p:clrMapOvr>
-  <mc:AlternateContent xmlns:mc="http://schemas.openxmlformats.org/markup-compatibility/2006">
-    <mc:Choice xmlns:p14="http://schemas.microsoft.com/office/powerpoint/2010/main" Requires="p14">
+  <mc:AlternateContent xmlns:mc="http://schemas.openxmlformats.org/markup-compatibility/2006" xmlns:p14="http://schemas.microsoft.com/office/powerpoint/2010/main">
+    <mc:Choice Requires="p14">
       <p:transition spd="slow" p14:dur="1200">
         <p14:prism/>
       </p:transition>
     </mc:Choice>
-    <mc:Fallback>
+    <mc:Fallback xmlns="">
       <p:transition spd="slow">
         <p:fade/>
       </p:transition>
@@ -36928,13 +36932,13 @@
   <p:clrMapOvr>
     <a:masterClrMapping/>
   </p:clrMapOvr>
-  <mc:AlternateContent xmlns:mc="http://schemas.openxmlformats.org/markup-compatibility/2006">
-    <mc:Choice xmlns:p14="http://schemas.microsoft.com/office/powerpoint/2010/main" Requires="p14">
+  <mc:AlternateContent xmlns:mc="http://schemas.openxmlformats.org/markup-compatibility/2006" xmlns:p14="http://schemas.microsoft.com/office/powerpoint/2010/main">
+    <mc:Choice Requires="p14">
       <p:transition spd="slow" p14:dur="1200">
         <p14:prism/>
       </p:transition>
     </mc:Choice>
-    <mc:Fallback>
+    <mc:Fallback xmlns="">
       <p:transition spd="slow">
         <p:fade/>
       </p:transition>
@@ -37171,13 +37175,13 @@
   <p:clrMapOvr>
     <a:masterClrMapping/>
   </p:clrMapOvr>
-  <mc:AlternateContent xmlns:mc="http://schemas.openxmlformats.org/markup-compatibility/2006">
-    <mc:Choice xmlns:p14="http://schemas.microsoft.com/office/powerpoint/2010/main" Requires="p14">
+  <mc:AlternateContent xmlns:mc="http://schemas.openxmlformats.org/markup-compatibility/2006" xmlns:p14="http://schemas.microsoft.com/office/powerpoint/2010/main">
+    <mc:Choice Requires="p14">
       <p:transition spd="slow" p14:dur="1200">
         <p14:prism/>
       </p:transition>
     </mc:Choice>
-    <mc:Fallback>
+    <mc:Fallback xmlns="">
       <p:transition spd="slow">
         <p:fade/>
       </p:transition>
@@ -37459,13 +37463,13 @@
   <p:clrMapOvr>
     <a:masterClrMapping/>
   </p:clrMapOvr>
-  <mc:AlternateContent xmlns:mc="http://schemas.openxmlformats.org/markup-compatibility/2006">
-    <mc:Choice xmlns:p15="http://schemas.microsoft.com/office/powerpoint/2012/main" Requires="p15">
+  <mc:AlternateContent xmlns:mc="http://schemas.openxmlformats.org/markup-compatibility/2006" xmlns:p15="http://schemas.microsoft.com/office/powerpoint/2012/main">
+    <mc:Choice Requires="p15">
       <p:transition xmlns:p14="http://schemas.microsoft.com/office/powerpoint/2010/main" spd="slow" p14:dur="1250">
         <p15:prstTrans prst="peelOff"/>
       </p:transition>
     </mc:Choice>
-    <mc:Fallback>
+    <mc:Fallback xmlns="">
       <p:transition spd="slow">
         <p:fade/>
       </p:transition>
@@ -40904,13 +40908,13 @@
   <p:clrMapOvr>
     <a:masterClrMapping/>
   </p:clrMapOvr>
-  <mc:AlternateContent xmlns:mc="http://schemas.openxmlformats.org/markup-compatibility/2006">
-    <mc:Choice xmlns:p14="http://schemas.microsoft.com/office/powerpoint/2010/main" Requires="p14">
+  <mc:AlternateContent xmlns:mc="http://schemas.openxmlformats.org/markup-compatibility/2006" xmlns:p14="http://schemas.microsoft.com/office/powerpoint/2010/main">
+    <mc:Choice Requires="p14">
       <p:transition spd="slow" p14:dur="1200">
         <p14:prism/>
       </p:transition>
     </mc:Choice>
-    <mc:Fallback>
+    <mc:Fallback xmlns="">
       <p:transition spd="slow">
         <p:fade/>
       </p:transition>
@@ -41045,13 +41049,13 @@
   <p:clrMapOvr>
     <a:masterClrMapping/>
   </p:clrMapOvr>
-  <mc:AlternateContent xmlns:mc="http://schemas.openxmlformats.org/markup-compatibility/2006">
-    <mc:Choice xmlns:p14="http://schemas.microsoft.com/office/powerpoint/2010/main" Requires="p14">
+  <mc:AlternateContent xmlns:mc="http://schemas.openxmlformats.org/markup-compatibility/2006" xmlns:p14="http://schemas.microsoft.com/office/powerpoint/2010/main">
+    <mc:Choice Requires="p14">
       <p:transition spd="slow" p14:dur="1200">
         <p14:prism/>
       </p:transition>
     </mc:Choice>
-    <mc:Fallback>
+    <mc:Fallback xmlns="">
       <p:transition spd="slow">
         <p:fade/>
       </p:transition>
@@ -42453,2766 +42457,36 @@
           </a:p>
         </p:txBody>
       </p:sp>
-      <p:graphicFrame>
-        <p:nvGraphicFramePr>
-          <p:cNvPr id="247" name="Google Shape;247;hfdfb8fb64a5011c_1_72"/>
-          <p:cNvGraphicFramePr/>
+      <p:pic>
+        <p:nvPicPr>
+          <p:cNvPr id="3" name="Imagen 2">
+            <a:extLst>
+              <a:ext uri="{FF2B5EF4-FFF2-40B4-BE49-F238E27FC236}">
+                <a16:creationId xmlns:a16="http://schemas.microsoft.com/office/drawing/2014/main" id="{E8F815E0-781D-8BCB-4247-34BCD358BCBE}"/>
+              </a:ext>
+            </a:extLst>
+          </p:cNvPr>
+          <p:cNvPicPr>
+            <a:picLocks noChangeAspect="1"/>
+          </p:cNvPicPr>
           <p:nvPr/>
-        </p:nvGraphicFramePr>
-        <p:xfrm>
-          <a:off x="119375" y="1338600"/>
-          <a:ext cx="11953225" cy="4473650"/>
-        </p:xfrm>
-        <a:graphic>
-          <a:graphicData uri="http://schemas.openxmlformats.org/drawingml/2006/table">
-            <a:tbl>
-              <a:tblPr>
-                <a:noFill/>
-                <a:tableStyleId>{28940ED5-32B1-469B-8B4F-D22008600FFA}</a:tableStyleId>
-              </a:tblPr>
-              <a:tblGrid>
-                <a:gridCol w="411200">
-                  <a:extLst>
-                    <a:ext uri="{9D8B030D-6E8A-4147-A177-3AD203B41FA5}">
-                      <a16:colId xmlns:a16="http://schemas.microsoft.com/office/drawing/2014/main" val="20000"/>
-                    </a:ext>
-                  </a:extLst>
-                </a:gridCol>
-                <a:gridCol w="1252325">
-                  <a:extLst>
-                    <a:ext uri="{9D8B030D-6E8A-4147-A177-3AD203B41FA5}">
-                      <a16:colId xmlns:a16="http://schemas.microsoft.com/office/drawing/2014/main" val="20001"/>
-                    </a:ext>
-                  </a:extLst>
-                </a:gridCol>
-                <a:gridCol w="2869150">
-                  <a:extLst>
-                    <a:ext uri="{9D8B030D-6E8A-4147-A177-3AD203B41FA5}">
-                      <a16:colId xmlns:a16="http://schemas.microsoft.com/office/drawing/2014/main" val="20002"/>
-                    </a:ext>
-                  </a:extLst>
-                </a:gridCol>
-                <a:gridCol w="616825">
-                  <a:extLst>
-                    <a:ext uri="{9D8B030D-6E8A-4147-A177-3AD203B41FA5}">
-                      <a16:colId xmlns:a16="http://schemas.microsoft.com/office/drawing/2014/main" val="20003"/>
-                    </a:ext>
-                  </a:extLst>
-                </a:gridCol>
-                <a:gridCol w="1037375">
-                  <a:extLst>
-                    <a:ext uri="{9D8B030D-6E8A-4147-A177-3AD203B41FA5}">
-                      <a16:colId xmlns:a16="http://schemas.microsoft.com/office/drawing/2014/main" val="20004"/>
-                    </a:ext>
-                  </a:extLst>
-                </a:gridCol>
-                <a:gridCol w="2869150">
-                  <a:extLst>
-                    <a:ext uri="{9D8B030D-6E8A-4147-A177-3AD203B41FA5}">
-                      <a16:colId xmlns:a16="http://schemas.microsoft.com/office/drawing/2014/main" val="20005"/>
-                    </a:ext>
-                  </a:extLst>
-                </a:gridCol>
-                <a:gridCol w="831775">
-                  <a:extLst>
-                    <a:ext uri="{9D8B030D-6E8A-4147-A177-3AD203B41FA5}">
-                      <a16:colId xmlns:a16="http://schemas.microsoft.com/office/drawing/2014/main" val="20006"/>
-                    </a:ext>
-                  </a:extLst>
-                </a:gridCol>
-                <a:gridCol w="616825">
-                  <a:extLst>
-                    <a:ext uri="{9D8B030D-6E8A-4147-A177-3AD203B41FA5}">
-                      <a16:colId xmlns:a16="http://schemas.microsoft.com/office/drawing/2014/main" val="20007"/>
-                    </a:ext>
-                  </a:extLst>
-                </a:gridCol>
-                <a:gridCol w="831775">
-                  <a:extLst>
-                    <a:ext uri="{9D8B030D-6E8A-4147-A177-3AD203B41FA5}">
-                      <a16:colId xmlns:a16="http://schemas.microsoft.com/office/drawing/2014/main" val="20008"/>
-                    </a:ext>
-                  </a:extLst>
-                </a:gridCol>
-                <a:gridCol w="616825">
-                  <a:extLst>
-                    <a:ext uri="{9D8B030D-6E8A-4147-A177-3AD203B41FA5}">
-                      <a16:colId xmlns:a16="http://schemas.microsoft.com/office/drawing/2014/main" val="20009"/>
-                    </a:ext>
-                  </a:extLst>
-                </a:gridCol>
-              </a:tblGrid>
-              <a:tr h="654250">
-                <a:tc>
-                  <a:txBody>
-                    <a:bodyPr/>
-                    <a:lstStyle/>
-                    <a:p>
-                      <a:pPr marL="0" lvl="0" indent="0" algn="ctr" rtl="0">
-                        <a:lnSpc>
-                          <a:spcPct val="115000"/>
-                        </a:lnSpc>
-                        <a:spcBef>
-                          <a:spcPts val="0"/>
-                        </a:spcBef>
-                        <a:spcAft>
-                          <a:spcPts val="0"/>
-                        </a:spcAft>
-                        <a:buNone/>
-                      </a:pPr>
-                      <a:r>
-                        <a:rPr lang="es-CL" sz="1100" b="1">
-                          <a:solidFill>
-                            <a:srgbClr val="FFFFFF"/>
-                          </a:solidFill>
-                        </a:rPr>
-                        <a:t>ID</a:t>
-                      </a:r>
-                      <a:endParaRPr sz="1100" b="1">
-                        <a:solidFill>
-                          <a:srgbClr val="FFFFFF"/>
-                        </a:solidFill>
-                      </a:endParaRPr>
-                    </a:p>
-                  </a:txBody>
-                  <a:tcPr marL="28575" marR="28575" marT="91425" marB="91425" anchor="ctr">
-                    <a:lnL w="9525" cap="flat" cmpd="sng">
-                      <a:solidFill>
-                        <a:srgbClr val="CCCCCC"/>
-                      </a:solidFill>
-                      <a:prstDash val="solid"/>
-                      <a:round/>
-                      <a:headEnd type="none" w="sm" len="sm"/>
-                      <a:tailEnd type="none" w="sm" len="sm"/>
-                    </a:lnL>
-                    <a:lnR w="9525" cap="flat" cmpd="sng">
-                      <a:solidFill>
-                        <a:srgbClr val="CCCCCC"/>
-                      </a:solidFill>
-                      <a:prstDash val="solid"/>
-                      <a:round/>
-                      <a:headEnd type="none" w="sm" len="sm"/>
-                      <a:tailEnd type="none" w="sm" len="sm"/>
-                    </a:lnR>
-                    <a:lnT w="9525" cap="flat" cmpd="sng">
-                      <a:solidFill>
-                        <a:srgbClr val="CCCCCC"/>
-                      </a:solidFill>
-                      <a:prstDash val="solid"/>
-                      <a:round/>
-                      <a:headEnd type="none" w="sm" len="sm"/>
-                      <a:tailEnd type="none" w="sm" len="sm"/>
-                    </a:lnT>
-                    <a:lnB w="9525" cap="flat" cmpd="sng">
-                      <a:solidFill>
-                        <a:srgbClr val="CCCCCC"/>
-                      </a:solidFill>
-                      <a:prstDash val="solid"/>
-                      <a:round/>
-                      <a:headEnd type="none" w="sm" len="sm"/>
-                      <a:tailEnd type="none" w="sm" len="sm"/>
-                    </a:lnB>
-                    <a:solidFill>
-                      <a:srgbClr val="2E5C8A"/>
-                    </a:solidFill>
-                  </a:tcPr>
-                </a:tc>
-                <a:tc>
-                  <a:txBody>
-                    <a:bodyPr/>
-                    <a:lstStyle/>
-                    <a:p>
-                      <a:pPr marL="0" lvl="0" indent="0" algn="ctr" rtl="0">
-                        <a:lnSpc>
-                          <a:spcPct val="115000"/>
-                        </a:lnSpc>
-                        <a:spcBef>
-                          <a:spcPts val="0"/>
-                        </a:spcBef>
-                        <a:spcAft>
-                          <a:spcPts val="0"/>
-                        </a:spcAft>
-                        <a:buNone/>
-                      </a:pPr>
-                      <a:r>
-                        <a:rPr lang="es-CL" sz="1100" b="1">
-                          <a:solidFill>
-                            <a:srgbClr val="FFFFFF"/>
-                          </a:solidFill>
-                        </a:rPr>
-                        <a:t>Épica</a:t>
-                      </a:r>
-                      <a:endParaRPr sz="1100" b="1">
-                        <a:solidFill>
-                          <a:srgbClr val="FFFFFF"/>
-                        </a:solidFill>
-                      </a:endParaRPr>
-                    </a:p>
-                  </a:txBody>
-                  <a:tcPr marL="28575" marR="28575" marT="91425" marB="91425" anchor="ctr">
-                    <a:lnL w="9525" cap="flat" cmpd="sng">
-                      <a:solidFill>
-                        <a:srgbClr val="CCCCCC"/>
-                      </a:solidFill>
-                      <a:prstDash val="solid"/>
-                      <a:round/>
-                      <a:headEnd type="none" w="sm" len="sm"/>
-                      <a:tailEnd type="none" w="sm" len="sm"/>
-                    </a:lnL>
-                    <a:lnR w="9525" cap="flat" cmpd="sng">
-                      <a:solidFill>
-                        <a:srgbClr val="CCCCCC"/>
-                      </a:solidFill>
-                      <a:prstDash val="solid"/>
-                      <a:round/>
-                      <a:headEnd type="none" w="sm" len="sm"/>
-                      <a:tailEnd type="none" w="sm" len="sm"/>
-                    </a:lnR>
-                    <a:lnT w="9525" cap="flat" cmpd="sng">
-                      <a:solidFill>
-                        <a:srgbClr val="CCCCCC"/>
-                      </a:solidFill>
-                      <a:prstDash val="solid"/>
-                      <a:round/>
-                      <a:headEnd type="none" w="sm" len="sm"/>
-                      <a:tailEnd type="none" w="sm" len="sm"/>
-                    </a:lnT>
-                    <a:lnB w="9525" cap="flat" cmpd="sng">
-                      <a:solidFill>
-                        <a:srgbClr val="CCCCCC"/>
-                      </a:solidFill>
-                      <a:prstDash val="solid"/>
-                      <a:round/>
-                      <a:headEnd type="none" w="sm" len="sm"/>
-                      <a:tailEnd type="none" w="sm" len="sm"/>
-                    </a:lnB>
-                    <a:solidFill>
-                      <a:srgbClr val="2E5C8A"/>
-                    </a:solidFill>
-                  </a:tcPr>
-                </a:tc>
-                <a:tc>
-                  <a:txBody>
-                    <a:bodyPr/>
-                    <a:lstStyle/>
-                    <a:p>
-                      <a:pPr marL="0" lvl="0" indent="0" algn="ctr" rtl="0">
-                        <a:lnSpc>
-                          <a:spcPct val="115000"/>
-                        </a:lnSpc>
-                        <a:spcBef>
-                          <a:spcPts val="0"/>
-                        </a:spcBef>
-                        <a:spcAft>
-                          <a:spcPts val="0"/>
-                        </a:spcAft>
-                        <a:buNone/>
-                      </a:pPr>
-                      <a:r>
-                        <a:rPr lang="es-CL" sz="1100" b="1">
-                          <a:solidFill>
-                            <a:srgbClr val="FFFFFF"/>
-                          </a:solidFill>
-                        </a:rPr>
-                        <a:t>Historia de Usuario</a:t>
-                      </a:r>
-                      <a:endParaRPr sz="1100" b="1">
-                        <a:solidFill>
-                          <a:srgbClr val="FFFFFF"/>
-                        </a:solidFill>
-                      </a:endParaRPr>
-                    </a:p>
-                  </a:txBody>
-                  <a:tcPr marL="28575" marR="28575" marT="91425" marB="91425" anchor="ctr">
-                    <a:lnL w="9525" cap="flat" cmpd="sng">
-                      <a:solidFill>
-                        <a:srgbClr val="CCCCCC"/>
-                      </a:solidFill>
-                      <a:prstDash val="solid"/>
-                      <a:round/>
-                      <a:headEnd type="none" w="sm" len="sm"/>
-                      <a:tailEnd type="none" w="sm" len="sm"/>
-                    </a:lnL>
-                    <a:lnR w="9525" cap="flat" cmpd="sng">
-                      <a:solidFill>
-                        <a:srgbClr val="CCCCCC"/>
-                      </a:solidFill>
-                      <a:prstDash val="solid"/>
-                      <a:round/>
-                      <a:headEnd type="none" w="sm" len="sm"/>
-                      <a:tailEnd type="none" w="sm" len="sm"/>
-                    </a:lnR>
-                    <a:lnT w="9525" cap="flat" cmpd="sng">
-                      <a:solidFill>
-                        <a:srgbClr val="CCCCCC"/>
-                      </a:solidFill>
-                      <a:prstDash val="solid"/>
-                      <a:round/>
-                      <a:headEnd type="none" w="sm" len="sm"/>
-                      <a:tailEnd type="none" w="sm" len="sm"/>
-                    </a:lnT>
-                    <a:lnB w="9525" cap="flat" cmpd="sng">
-                      <a:solidFill>
-                        <a:srgbClr val="CCCCCC"/>
-                      </a:solidFill>
-                      <a:prstDash val="solid"/>
-                      <a:round/>
-                      <a:headEnd type="none" w="sm" len="sm"/>
-                      <a:tailEnd type="none" w="sm" len="sm"/>
-                    </a:lnB>
-                    <a:solidFill>
-                      <a:srgbClr val="2E5C8A"/>
-                    </a:solidFill>
-                  </a:tcPr>
-                </a:tc>
-                <a:tc>
-                  <a:txBody>
-                    <a:bodyPr/>
-                    <a:lstStyle/>
-                    <a:p>
-                      <a:pPr marL="0" lvl="0" indent="0" algn="ctr" rtl="0">
-                        <a:lnSpc>
-                          <a:spcPct val="115000"/>
-                        </a:lnSpc>
-                        <a:spcBef>
-                          <a:spcPts val="0"/>
-                        </a:spcBef>
-                        <a:spcAft>
-                          <a:spcPts val="0"/>
-                        </a:spcAft>
-                        <a:buNone/>
-                      </a:pPr>
-                      <a:r>
-                        <a:rPr lang="es-CL" sz="1100" b="1">
-                          <a:solidFill>
-                            <a:srgbClr val="FFFFFF"/>
-                          </a:solidFill>
-                        </a:rPr>
-                        <a:t>Tipo</a:t>
-                      </a:r>
-                      <a:endParaRPr sz="1100" b="1">
-                        <a:solidFill>
-                          <a:srgbClr val="FFFFFF"/>
-                        </a:solidFill>
-                      </a:endParaRPr>
-                    </a:p>
-                  </a:txBody>
-                  <a:tcPr marL="28575" marR="28575" marT="91425" marB="91425" anchor="ctr">
-                    <a:lnL w="9525" cap="flat" cmpd="sng">
-                      <a:solidFill>
-                        <a:srgbClr val="CCCCCC"/>
-                      </a:solidFill>
-                      <a:prstDash val="solid"/>
-                      <a:round/>
-                      <a:headEnd type="none" w="sm" len="sm"/>
-                      <a:tailEnd type="none" w="sm" len="sm"/>
-                    </a:lnL>
-                    <a:lnR w="9525" cap="flat" cmpd="sng">
-                      <a:solidFill>
-                        <a:srgbClr val="CCCCCC"/>
-                      </a:solidFill>
-                      <a:prstDash val="solid"/>
-                      <a:round/>
-                      <a:headEnd type="none" w="sm" len="sm"/>
-                      <a:tailEnd type="none" w="sm" len="sm"/>
-                    </a:lnR>
-                    <a:lnT w="9525" cap="flat" cmpd="sng">
-                      <a:solidFill>
-                        <a:srgbClr val="CCCCCC"/>
-                      </a:solidFill>
-                      <a:prstDash val="solid"/>
-                      <a:round/>
-                      <a:headEnd type="none" w="sm" len="sm"/>
-                      <a:tailEnd type="none" w="sm" len="sm"/>
-                    </a:lnT>
-                    <a:lnB w="9525" cap="flat" cmpd="sng">
-                      <a:solidFill>
-                        <a:srgbClr val="CCCCCC"/>
-                      </a:solidFill>
-                      <a:prstDash val="solid"/>
-                      <a:round/>
-                      <a:headEnd type="none" w="sm" len="sm"/>
-                      <a:tailEnd type="none" w="sm" len="sm"/>
-                    </a:lnB>
-                    <a:solidFill>
-                      <a:srgbClr val="2E5C8A"/>
-                    </a:solidFill>
-                  </a:tcPr>
-                </a:tc>
-                <a:tc>
-                  <a:txBody>
-                    <a:bodyPr/>
-                    <a:lstStyle/>
-                    <a:p>
-                      <a:pPr marL="0" lvl="0" indent="0" algn="ctr" rtl="0">
-                        <a:lnSpc>
-                          <a:spcPct val="115000"/>
-                        </a:lnSpc>
-                        <a:spcBef>
-                          <a:spcPts val="0"/>
-                        </a:spcBef>
-                        <a:spcAft>
-                          <a:spcPts val="0"/>
-                        </a:spcAft>
-                        <a:buNone/>
-                      </a:pPr>
-                      <a:r>
-                        <a:rPr lang="es-CL" sz="1100" b="1">
-                          <a:solidFill>
-                            <a:srgbClr val="FFFFFF"/>
-                          </a:solidFill>
-                        </a:rPr>
-                        <a:t>Actores</a:t>
-                      </a:r>
-                      <a:endParaRPr sz="1100" b="1">
-                        <a:solidFill>
-                          <a:srgbClr val="FFFFFF"/>
-                        </a:solidFill>
-                      </a:endParaRPr>
-                    </a:p>
-                  </a:txBody>
-                  <a:tcPr marL="28575" marR="28575" marT="91425" marB="91425" anchor="ctr">
-                    <a:lnL w="9525" cap="flat" cmpd="sng">
-                      <a:solidFill>
-                        <a:srgbClr val="CCCCCC"/>
-                      </a:solidFill>
-                      <a:prstDash val="solid"/>
-                      <a:round/>
-                      <a:headEnd type="none" w="sm" len="sm"/>
-                      <a:tailEnd type="none" w="sm" len="sm"/>
-                    </a:lnL>
-                    <a:lnR w="9525" cap="flat" cmpd="sng">
-                      <a:solidFill>
-                        <a:srgbClr val="CCCCCC"/>
-                      </a:solidFill>
-                      <a:prstDash val="solid"/>
-                      <a:round/>
-                      <a:headEnd type="none" w="sm" len="sm"/>
-                      <a:tailEnd type="none" w="sm" len="sm"/>
-                    </a:lnR>
-                    <a:lnT w="9525" cap="flat" cmpd="sng">
-                      <a:solidFill>
-                        <a:srgbClr val="CCCCCC"/>
-                      </a:solidFill>
-                      <a:prstDash val="solid"/>
-                      <a:round/>
-                      <a:headEnd type="none" w="sm" len="sm"/>
-                      <a:tailEnd type="none" w="sm" len="sm"/>
-                    </a:lnT>
-                    <a:lnB w="9525" cap="flat" cmpd="sng">
-                      <a:solidFill>
-                        <a:srgbClr val="CCCCCC"/>
-                      </a:solidFill>
-                      <a:prstDash val="solid"/>
-                      <a:round/>
-                      <a:headEnd type="none" w="sm" len="sm"/>
-                      <a:tailEnd type="none" w="sm" len="sm"/>
-                    </a:lnB>
-                    <a:solidFill>
-                      <a:srgbClr val="2E5C8A"/>
-                    </a:solidFill>
-                  </a:tcPr>
-                </a:tc>
-                <a:tc>
-                  <a:txBody>
-                    <a:bodyPr/>
-                    <a:lstStyle/>
-                    <a:p>
-                      <a:pPr marL="0" lvl="0" indent="0" algn="ctr" rtl="0">
-                        <a:lnSpc>
-                          <a:spcPct val="115000"/>
-                        </a:lnSpc>
-                        <a:spcBef>
-                          <a:spcPts val="0"/>
-                        </a:spcBef>
-                        <a:spcAft>
-                          <a:spcPts val="0"/>
-                        </a:spcAft>
-                        <a:buNone/>
-                      </a:pPr>
-                      <a:r>
-                        <a:rPr lang="es-CL" sz="1100" b="1">
-                          <a:solidFill>
-                            <a:srgbClr val="FFFFFF"/>
-                          </a:solidFill>
-                        </a:rPr>
-                        <a:t>Criterio de Aceptación</a:t>
-                      </a:r>
-                      <a:endParaRPr sz="1100" b="1">
-                        <a:solidFill>
-                          <a:srgbClr val="FFFFFF"/>
-                        </a:solidFill>
-                      </a:endParaRPr>
-                    </a:p>
-                  </a:txBody>
-                  <a:tcPr marL="28575" marR="28575" marT="91425" marB="91425" anchor="ctr">
-                    <a:lnL w="9525" cap="flat" cmpd="sng">
-                      <a:solidFill>
-                        <a:srgbClr val="CCCCCC"/>
-                      </a:solidFill>
-                      <a:prstDash val="solid"/>
-                      <a:round/>
-                      <a:headEnd type="none" w="sm" len="sm"/>
-                      <a:tailEnd type="none" w="sm" len="sm"/>
-                    </a:lnL>
-                    <a:lnR w="9525" cap="flat" cmpd="sng">
-                      <a:solidFill>
-                        <a:srgbClr val="CCCCCC"/>
-                      </a:solidFill>
-                      <a:prstDash val="solid"/>
-                      <a:round/>
-                      <a:headEnd type="none" w="sm" len="sm"/>
-                      <a:tailEnd type="none" w="sm" len="sm"/>
-                    </a:lnR>
-                    <a:lnT w="9525" cap="flat" cmpd="sng">
-                      <a:solidFill>
-                        <a:srgbClr val="CCCCCC"/>
-                      </a:solidFill>
-                      <a:prstDash val="solid"/>
-                      <a:round/>
-                      <a:headEnd type="none" w="sm" len="sm"/>
-                      <a:tailEnd type="none" w="sm" len="sm"/>
-                    </a:lnT>
-                    <a:lnB w="9525" cap="flat" cmpd="sng">
-                      <a:solidFill>
-                        <a:srgbClr val="CCCCCC"/>
-                      </a:solidFill>
-                      <a:prstDash val="solid"/>
-                      <a:round/>
-                      <a:headEnd type="none" w="sm" len="sm"/>
-                      <a:tailEnd type="none" w="sm" len="sm"/>
-                    </a:lnB>
-                    <a:solidFill>
-                      <a:srgbClr val="2E5C8A"/>
-                    </a:solidFill>
-                  </a:tcPr>
-                </a:tc>
-                <a:tc>
-                  <a:txBody>
-                    <a:bodyPr/>
-                    <a:lstStyle/>
-                    <a:p>
-                      <a:pPr marL="0" lvl="0" indent="0" algn="ctr" rtl="0">
-                        <a:lnSpc>
-                          <a:spcPct val="115000"/>
-                        </a:lnSpc>
-                        <a:spcBef>
-                          <a:spcPts val="0"/>
-                        </a:spcBef>
-                        <a:spcAft>
-                          <a:spcPts val="0"/>
-                        </a:spcAft>
-                        <a:buNone/>
-                      </a:pPr>
-                      <a:r>
-                        <a:rPr lang="es-CL" sz="1100" b="1">
-                          <a:solidFill>
-                            <a:srgbClr val="FFFFFF"/>
-                          </a:solidFill>
-                        </a:rPr>
-                        <a:t>Prioridad (MoSCoW)</a:t>
-                      </a:r>
-                      <a:endParaRPr sz="1100" b="1">
-                        <a:solidFill>
-                          <a:srgbClr val="FFFFFF"/>
-                        </a:solidFill>
-                      </a:endParaRPr>
-                    </a:p>
-                  </a:txBody>
-                  <a:tcPr marL="28575" marR="28575" marT="91425" marB="91425" anchor="ctr">
-                    <a:lnL w="9525" cap="flat" cmpd="sng">
-                      <a:solidFill>
-                        <a:srgbClr val="CCCCCC"/>
-                      </a:solidFill>
-                      <a:prstDash val="solid"/>
-                      <a:round/>
-                      <a:headEnd type="none" w="sm" len="sm"/>
-                      <a:tailEnd type="none" w="sm" len="sm"/>
-                    </a:lnL>
-                    <a:lnR w="9525" cap="flat" cmpd="sng">
-                      <a:solidFill>
-                        <a:srgbClr val="CCCCCC"/>
-                      </a:solidFill>
-                      <a:prstDash val="solid"/>
-                      <a:round/>
-                      <a:headEnd type="none" w="sm" len="sm"/>
-                      <a:tailEnd type="none" w="sm" len="sm"/>
-                    </a:lnR>
-                    <a:lnT w="9525" cap="flat" cmpd="sng">
-                      <a:solidFill>
-                        <a:srgbClr val="CCCCCC"/>
-                      </a:solidFill>
-                      <a:prstDash val="solid"/>
-                      <a:round/>
-                      <a:headEnd type="none" w="sm" len="sm"/>
-                      <a:tailEnd type="none" w="sm" len="sm"/>
-                    </a:lnT>
-                    <a:lnB w="9525" cap="flat" cmpd="sng">
-                      <a:solidFill>
-                        <a:srgbClr val="CCCCCC"/>
-                      </a:solidFill>
-                      <a:prstDash val="solid"/>
-                      <a:round/>
-                      <a:headEnd type="none" w="sm" len="sm"/>
-                      <a:tailEnd type="none" w="sm" len="sm"/>
-                    </a:lnB>
-                    <a:solidFill>
-                      <a:srgbClr val="2E5C8A"/>
-                    </a:solidFill>
-                  </a:tcPr>
-                </a:tc>
-                <a:tc>
-                  <a:txBody>
-                    <a:bodyPr/>
-                    <a:lstStyle/>
-                    <a:p>
-                      <a:pPr marL="0" lvl="0" indent="0" algn="ctr" rtl="0">
-                        <a:lnSpc>
-                          <a:spcPct val="115000"/>
-                        </a:lnSpc>
-                        <a:spcBef>
-                          <a:spcPts val="0"/>
-                        </a:spcBef>
-                        <a:spcAft>
-                          <a:spcPts val="0"/>
-                        </a:spcAft>
-                        <a:buNone/>
-                      </a:pPr>
-                      <a:r>
-                        <a:rPr lang="es-CL" sz="1100" b="1">
-                          <a:solidFill>
-                            <a:srgbClr val="FFFFFF"/>
-                          </a:solidFill>
-                        </a:rPr>
-                        <a:t>Story Points</a:t>
-                      </a:r>
-                      <a:endParaRPr sz="1100" b="1">
-                        <a:solidFill>
-                          <a:srgbClr val="FFFFFF"/>
-                        </a:solidFill>
-                      </a:endParaRPr>
-                    </a:p>
-                  </a:txBody>
-                  <a:tcPr marL="28575" marR="28575" marT="91425" marB="91425" anchor="ctr">
-                    <a:lnL w="9525" cap="flat" cmpd="sng">
-                      <a:solidFill>
-                        <a:srgbClr val="CCCCCC"/>
-                      </a:solidFill>
-                      <a:prstDash val="solid"/>
-                      <a:round/>
-                      <a:headEnd type="none" w="sm" len="sm"/>
-                      <a:tailEnd type="none" w="sm" len="sm"/>
-                    </a:lnL>
-                    <a:lnR w="9525" cap="flat" cmpd="sng">
-                      <a:solidFill>
-                        <a:srgbClr val="CCCCCC"/>
-                      </a:solidFill>
-                      <a:prstDash val="solid"/>
-                      <a:round/>
-                      <a:headEnd type="none" w="sm" len="sm"/>
-                      <a:tailEnd type="none" w="sm" len="sm"/>
-                    </a:lnR>
-                    <a:lnT w="9525" cap="flat" cmpd="sng">
-                      <a:solidFill>
-                        <a:srgbClr val="CCCCCC"/>
-                      </a:solidFill>
-                      <a:prstDash val="solid"/>
-                      <a:round/>
-                      <a:headEnd type="none" w="sm" len="sm"/>
-                      <a:tailEnd type="none" w="sm" len="sm"/>
-                    </a:lnT>
-                    <a:lnB w="9525" cap="flat" cmpd="sng">
-                      <a:solidFill>
-                        <a:srgbClr val="CCCCCC"/>
-                      </a:solidFill>
-                      <a:prstDash val="solid"/>
-                      <a:round/>
-                      <a:headEnd type="none" w="sm" len="sm"/>
-                      <a:tailEnd type="none" w="sm" len="sm"/>
-                    </a:lnB>
-                    <a:solidFill>
-                      <a:srgbClr val="2E5C8A"/>
-                    </a:solidFill>
-                  </a:tcPr>
-                </a:tc>
-                <a:tc>
-                  <a:txBody>
-                    <a:bodyPr/>
-                    <a:lstStyle/>
-                    <a:p>
-                      <a:pPr marL="0" lvl="0" indent="0" algn="ctr" rtl="0">
-                        <a:lnSpc>
-                          <a:spcPct val="115000"/>
-                        </a:lnSpc>
-                        <a:spcBef>
-                          <a:spcPts val="0"/>
-                        </a:spcBef>
-                        <a:spcAft>
-                          <a:spcPts val="0"/>
-                        </a:spcAft>
-                        <a:buNone/>
-                      </a:pPr>
-                      <a:r>
-                        <a:rPr lang="es-CL" sz="1100" b="1">
-                          <a:solidFill>
-                            <a:srgbClr val="FFFFFF"/>
-                          </a:solidFill>
-                        </a:rPr>
-                        <a:t>Sprint planificado</a:t>
-                      </a:r>
-                      <a:endParaRPr sz="1100" b="1">
-                        <a:solidFill>
-                          <a:srgbClr val="FFFFFF"/>
-                        </a:solidFill>
-                      </a:endParaRPr>
-                    </a:p>
-                  </a:txBody>
-                  <a:tcPr marL="28575" marR="28575" marT="91425" marB="91425" anchor="ctr">
-                    <a:lnL w="9525" cap="flat" cmpd="sng">
-                      <a:solidFill>
-                        <a:srgbClr val="CCCCCC"/>
-                      </a:solidFill>
-                      <a:prstDash val="solid"/>
-                      <a:round/>
-                      <a:headEnd type="none" w="sm" len="sm"/>
-                      <a:tailEnd type="none" w="sm" len="sm"/>
-                    </a:lnL>
-                    <a:lnR w="9525" cap="flat" cmpd="sng">
-                      <a:solidFill>
-                        <a:srgbClr val="CCCCCC"/>
-                      </a:solidFill>
-                      <a:prstDash val="solid"/>
-                      <a:round/>
-                      <a:headEnd type="none" w="sm" len="sm"/>
-                      <a:tailEnd type="none" w="sm" len="sm"/>
-                    </a:lnR>
-                    <a:lnT w="9525" cap="flat" cmpd="sng">
-                      <a:solidFill>
-                        <a:srgbClr val="CCCCCC"/>
-                      </a:solidFill>
-                      <a:prstDash val="solid"/>
-                      <a:round/>
-                      <a:headEnd type="none" w="sm" len="sm"/>
-                      <a:tailEnd type="none" w="sm" len="sm"/>
-                    </a:lnT>
-                    <a:lnB w="9525" cap="flat" cmpd="sng">
-                      <a:solidFill>
-                        <a:srgbClr val="CCCCCC"/>
-                      </a:solidFill>
-                      <a:prstDash val="solid"/>
-                      <a:round/>
-                      <a:headEnd type="none" w="sm" len="sm"/>
-                      <a:tailEnd type="none" w="sm" len="sm"/>
-                    </a:lnB>
-                    <a:solidFill>
-                      <a:srgbClr val="2E5C8A"/>
-                    </a:solidFill>
-                  </a:tcPr>
-                </a:tc>
-                <a:tc>
-                  <a:txBody>
-                    <a:bodyPr/>
-                    <a:lstStyle/>
-                    <a:p>
-                      <a:pPr marL="0" lvl="0" indent="0" algn="ctr" rtl="0">
-                        <a:lnSpc>
-                          <a:spcPct val="115000"/>
-                        </a:lnSpc>
-                        <a:spcBef>
-                          <a:spcPts val="0"/>
-                        </a:spcBef>
-                        <a:spcAft>
-                          <a:spcPts val="0"/>
-                        </a:spcAft>
-                        <a:buNone/>
-                      </a:pPr>
-                      <a:r>
-                        <a:rPr lang="es-CL" sz="1100" b="1">
-                          <a:solidFill>
-                            <a:srgbClr val="FFFFFF"/>
-                          </a:solidFill>
-                        </a:rPr>
-                        <a:t>Estado</a:t>
-                      </a:r>
-                      <a:endParaRPr sz="1100" b="1">
-                        <a:solidFill>
-                          <a:srgbClr val="FFFFFF"/>
-                        </a:solidFill>
-                      </a:endParaRPr>
-                    </a:p>
-                  </a:txBody>
-                  <a:tcPr marL="28575" marR="28575" marT="91425" marB="91425" anchor="ctr">
-                    <a:lnL w="9525" cap="flat" cmpd="sng">
-                      <a:solidFill>
-                        <a:srgbClr val="CCCCCC"/>
-                      </a:solidFill>
-                      <a:prstDash val="solid"/>
-                      <a:round/>
-                      <a:headEnd type="none" w="sm" len="sm"/>
-                      <a:tailEnd type="none" w="sm" len="sm"/>
-                    </a:lnL>
-                    <a:lnR w="9525" cap="flat" cmpd="sng">
-                      <a:solidFill>
-                        <a:srgbClr val="CCCCCC"/>
-                      </a:solidFill>
-                      <a:prstDash val="solid"/>
-                      <a:round/>
-                      <a:headEnd type="none" w="sm" len="sm"/>
-                      <a:tailEnd type="none" w="sm" len="sm"/>
-                    </a:lnR>
-                    <a:lnT w="9525" cap="flat" cmpd="sng">
-                      <a:solidFill>
-                        <a:srgbClr val="CCCCCC"/>
-                      </a:solidFill>
-                      <a:prstDash val="solid"/>
-                      <a:round/>
-                      <a:headEnd type="none" w="sm" len="sm"/>
-                      <a:tailEnd type="none" w="sm" len="sm"/>
-                    </a:lnT>
-                    <a:lnB w="9525" cap="flat" cmpd="sng">
-                      <a:solidFill>
-                        <a:srgbClr val="CCCCCC"/>
-                      </a:solidFill>
-                      <a:prstDash val="solid"/>
-                      <a:round/>
-                      <a:headEnd type="none" w="sm" len="sm"/>
-                      <a:tailEnd type="none" w="sm" len="sm"/>
-                    </a:lnB>
-                    <a:solidFill>
-                      <a:srgbClr val="2E5C8A"/>
-                    </a:solidFill>
-                  </a:tcPr>
-                </a:tc>
-                <a:extLst>
-                  <a:ext uri="{0D108BD9-81ED-4DB2-BD59-A6C34878D82A}">
-                    <a16:rowId xmlns:a16="http://schemas.microsoft.com/office/drawing/2014/main" val="10000"/>
-                  </a:ext>
-                </a:extLst>
-              </a:tr>
-              <a:tr h="1405750">
-                <a:tc>
-                  <a:txBody>
-                    <a:bodyPr/>
-                    <a:lstStyle/>
-                    <a:p>
-                      <a:pPr marL="0" lvl="0" indent="0" algn="l" rtl="0">
-                        <a:lnSpc>
-                          <a:spcPct val="115000"/>
-                        </a:lnSpc>
-                        <a:spcBef>
-                          <a:spcPts val="0"/>
-                        </a:spcBef>
-                        <a:spcAft>
-                          <a:spcPts val="0"/>
-                        </a:spcAft>
-                        <a:buNone/>
-                      </a:pPr>
-                      <a:r>
-                        <a:rPr lang="es-CL" sz="1000"/>
-                        <a:t>R.131</a:t>
-                      </a:r>
-                      <a:endParaRPr sz="1000"/>
-                    </a:p>
-                  </a:txBody>
-                  <a:tcPr marL="28575" marR="28575" marT="91425" marB="91425">
-                    <a:lnL w="9525" cap="flat" cmpd="sng">
-                      <a:solidFill>
-                        <a:srgbClr val="CCCCCC"/>
-                      </a:solidFill>
-                      <a:prstDash val="solid"/>
-                      <a:round/>
-                      <a:headEnd type="none" w="sm" len="sm"/>
-                      <a:tailEnd type="none" w="sm" len="sm"/>
-                    </a:lnL>
-                    <a:lnR w="9525" cap="flat" cmpd="sng">
-                      <a:solidFill>
-                        <a:srgbClr val="CCCCCC"/>
-                      </a:solidFill>
-                      <a:prstDash val="solid"/>
-                      <a:round/>
-                      <a:headEnd type="none" w="sm" len="sm"/>
-                      <a:tailEnd type="none" w="sm" len="sm"/>
-                    </a:lnR>
-                    <a:lnT w="9525" cap="flat" cmpd="sng">
-                      <a:solidFill>
-                        <a:srgbClr val="CCCCCC"/>
-                      </a:solidFill>
-                      <a:prstDash val="solid"/>
-                      <a:round/>
-                      <a:headEnd type="none" w="sm" len="sm"/>
-                      <a:tailEnd type="none" w="sm" len="sm"/>
-                    </a:lnT>
-                    <a:lnB w="9525" cap="flat" cmpd="sng">
-                      <a:solidFill>
-                        <a:srgbClr val="CCCCCC"/>
-                      </a:solidFill>
-                      <a:prstDash val="solid"/>
-                      <a:round/>
-                      <a:headEnd type="none" w="sm" len="sm"/>
-                      <a:tailEnd type="none" w="sm" len="sm"/>
-                    </a:lnB>
-                  </a:tcPr>
-                </a:tc>
-                <a:tc>
-                  <a:txBody>
-                    <a:bodyPr/>
-                    <a:lstStyle/>
-                    <a:p>
-                      <a:pPr marL="0" lvl="0" indent="0" algn="l" rtl="0">
-                        <a:lnSpc>
-                          <a:spcPct val="115000"/>
-                        </a:lnSpc>
-                        <a:spcBef>
-                          <a:spcPts val="0"/>
-                        </a:spcBef>
-                        <a:spcAft>
-                          <a:spcPts val="0"/>
-                        </a:spcAft>
-                        <a:buNone/>
-                      </a:pPr>
-                      <a:r>
-                        <a:rPr lang="es-CL" sz="1000"/>
-                        <a:t>Gestión del Encargado de Gimnasio</a:t>
-                      </a:r>
-                      <a:endParaRPr sz="1000"/>
-                    </a:p>
-                  </a:txBody>
-                  <a:tcPr marL="28575" marR="28575" marT="91425" marB="91425">
-                    <a:lnL w="9525" cap="flat" cmpd="sng">
-                      <a:solidFill>
-                        <a:srgbClr val="CCCCCC"/>
-                      </a:solidFill>
-                      <a:prstDash val="solid"/>
-                      <a:round/>
-                      <a:headEnd type="none" w="sm" len="sm"/>
-                      <a:tailEnd type="none" w="sm" len="sm"/>
-                    </a:lnL>
-                    <a:lnR w="9525" cap="flat" cmpd="sng">
-                      <a:solidFill>
-                        <a:srgbClr val="CCCCCC"/>
-                      </a:solidFill>
-                      <a:prstDash val="solid"/>
-                      <a:round/>
-                      <a:headEnd type="none" w="sm" len="sm"/>
-                      <a:tailEnd type="none" w="sm" len="sm"/>
-                    </a:lnR>
-                    <a:lnT w="9525" cap="flat" cmpd="sng">
-                      <a:solidFill>
-                        <a:srgbClr val="CCCCCC"/>
-                      </a:solidFill>
-                      <a:prstDash val="solid"/>
-                      <a:round/>
-                      <a:headEnd type="none" w="sm" len="sm"/>
-                      <a:tailEnd type="none" w="sm" len="sm"/>
-                    </a:lnT>
-                    <a:lnB w="9525" cap="flat" cmpd="sng">
-                      <a:solidFill>
-                        <a:srgbClr val="CCCCCC"/>
-                      </a:solidFill>
-                      <a:prstDash val="solid"/>
-                      <a:round/>
-                      <a:headEnd type="none" w="sm" len="sm"/>
-                      <a:tailEnd type="none" w="sm" len="sm"/>
-                    </a:lnB>
-                  </a:tcPr>
-                </a:tc>
-                <a:tc>
-                  <a:txBody>
-                    <a:bodyPr/>
-                    <a:lstStyle/>
-                    <a:p>
-                      <a:pPr marL="0" lvl="0" indent="0" algn="l" rtl="0">
-                        <a:lnSpc>
-                          <a:spcPct val="115000"/>
-                        </a:lnSpc>
-                        <a:spcBef>
-                          <a:spcPts val="0"/>
-                        </a:spcBef>
-                        <a:spcAft>
-                          <a:spcPts val="0"/>
-                        </a:spcAft>
-                        <a:buNone/>
-                      </a:pPr>
-                      <a:r>
-                        <a:rPr lang="es-CL" sz="1000"/>
-                        <a:t>Como encargado del gimnasio, quiero mostrar cómo cambian las mediciones del usuario entre evaluaciones, por ejemplo peso o presión, para permitir que el personal del gimnasio supervise y valide el proceso.</a:t>
-                      </a:r>
-                      <a:endParaRPr sz="1000"/>
-                    </a:p>
-                  </a:txBody>
-                  <a:tcPr marL="28575" marR="28575" marT="91425" marB="91425">
-                    <a:lnL w="9525" cap="flat" cmpd="sng">
-                      <a:solidFill>
-                        <a:srgbClr val="CCCCCC"/>
-                      </a:solidFill>
-                      <a:prstDash val="solid"/>
-                      <a:round/>
-                      <a:headEnd type="none" w="sm" len="sm"/>
-                      <a:tailEnd type="none" w="sm" len="sm"/>
-                    </a:lnL>
-                    <a:lnR w="9525" cap="flat" cmpd="sng">
-                      <a:solidFill>
-                        <a:srgbClr val="CCCCCC"/>
-                      </a:solidFill>
-                      <a:prstDash val="solid"/>
-                      <a:round/>
-                      <a:headEnd type="none" w="sm" len="sm"/>
-                      <a:tailEnd type="none" w="sm" len="sm"/>
-                    </a:lnR>
-                    <a:lnT w="9525" cap="flat" cmpd="sng">
-                      <a:solidFill>
-                        <a:srgbClr val="CCCCCC"/>
-                      </a:solidFill>
-                      <a:prstDash val="solid"/>
-                      <a:round/>
-                      <a:headEnd type="none" w="sm" len="sm"/>
-                      <a:tailEnd type="none" w="sm" len="sm"/>
-                    </a:lnT>
-                    <a:lnB w="9525" cap="flat" cmpd="sng">
-                      <a:solidFill>
-                        <a:srgbClr val="CCCCCC"/>
-                      </a:solidFill>
-                      <a:prstDash val="solid"/>
-                      <a:round/>
-                      <a:headEnd type="none" w="sm" len="sm"/>
-                      <a:tailEnd type="none" w="sm" len="sm"/>
-                    </a:lnB>
-                  </a:tcPr>
-                </a:tc>
-                <a:tc>
-                  <a:txBody>
-                    <a:bodyPr/>
-                    <a:lstStyle/>
-                    <a:p>
-                      <a:pPr marL="0" lvl="0" indent="0" algn="l" rtl="0">
-                        <a:lnSpc>
-                          <a:spcPct val="115000"/>
-                        </a:lnSpc>
-                        <a:spcBef>
-                          <a:spcPts val="0"/>
-                        </a:spcBef>
-                        <a:spcAft>
-                          <a:spcPts val="0"/>
-                        </a:spcAft>
-                        <a:buNone/>
-                      </a:pPr>
-                      <a:r>
-                        <a:rPr lang="es-CL" sz="1000"/>
-                        <a:t>Funcional</a:t>
-                      </a:r>
-                      <a:endParaRPr sz="1000"/>
-                    </a:p>
-                  </a:txBody>
-                  <a:tcPr marL="28575" marR="28575" marT="91425" marB="91425">
-                    <a:lnL w="9525" cap="flat" cmpd="sng">
-                      <a:solidFill>
-                        <a:srgbClr val="CCCCCC"/>
-                      </a:solidFill>
-                      <a:prstDash val="solid"/>
-                      <a:round/>
-                      <a:headEnd type="none" w="sm" len="sm"/>
-                      <a:tailEnd type="none" w="sm" len="sm"/>
-                    </a:lnL>
-                    <a:lnR w="9525" cap="flat" cmpd="sng">
-                      <a:solidFill>
-                        <a:srgbClr val="CCCCCC"/>
-                      </a:solidFill>
-                      <a:prstDash val="solid"/>
-                      <a:round/>
-                      <a:headEnd type="none" w="sm" len="sm"/>
-                      <a:tailEnd type="none" w="sm" len="sm"/>
-                    </a:lnR>
-                    <a:lnT w="9525" cap="flat" cmpd="sng">
-                      <a:solidFill>
-                        <a:srgbClr val="CCCCCC"/>
-                      </a:solidFill>
-                      <a:prstDash val="solid"/>
-                      <a:round/>
-                      <a:headEnd type="none" w="sm" len="sm"/>
-                      <a:tailEnd type="none" w="sm" len="sm"/>
-                    </a:lnT>
-                    <a:lnB w="9525" cap="flat" cmpd="sng">
-                      <a:solidFill>
-                        <a:srgbClr val="CCCCCC"/>
-                      </a:solidFill>
-                      <a:prstDash val="solid"/>
-                      <a:round/>
-                      <a:headEnd type="none" w="sm" len="sm"/>
-                      <a:tailEnd type="none" w="sm" len="sm"/>
-                    </a:lnB>
-                  </a:tcPr>
-                </a:tc>
-                <a:tc>
-                  <a:txBody>
-                    <a:bodyPr/>
-                    <a:lstStyle/>
-                    <a:p>
-                      <a:pPr marL="0" lvl="0" indent="0" algn="l" rtl="0">
-                        <a:lnSpc>
-                          <a:spcPct val="115000"/>
-                        </a:lnSpc>
-                        <a:spcBef>
-                          <a:spcPts val="0"/>
-                        </a:spcBef>
-                        <a:spcAft>
-                          <a:spcPts val="0"/>
-                        </a:spcAft>
-                        <a:buNone/>
-                      </a:pPr>
-                      <a:r>
-                        <a:rPr lang="es-CL" sz="1000"/>
-                        <a:t>Encargado del gimnasio</a:t>
-                      </a:r>
-                      <a:endParaRPr sz="1000"/>
-                    </a:p>
-                  </a:txBody>
-                  <a:tcPr marL="28575" marR="28575" marT="91425" marB="91425">
-                    <a:lnL w="9525" cap="flat" cmpd="sng">
-                      <a:solidFill>
-                        <a:srgbClr val="CCCCCC"/>
-                      </a:solidFill>
-                      <a:prstDash val="solid"/>
-                      <a:round/>
-                      <a:headEnd type="none" w="sm" len="sm"/>
-                      <a:tailEnd type="none" w="sm" len="sm"/>
-                    </a:lnL>
-                    <a:lnR w="9525" cap="flat" cmpd="sng">
-                      <a:solidFill>
-                        <a:srgbClr val="CCCCCC"/>
-                      </a:solidFill>
-                      <a:prstDash val="solid"/>
-                      <a:round/>
-                      <a:headEnd type="none" w="sm" len="sm"/>
-                      <a:tailEnd type="none" w="sm" len="sm"/>
-                    </a:lnR>
-                    <a:lnT w="9525" cap="flat" cmpd="sng">
-                      <a:solidFill>
-                        <a:srgbClr val="CCCCCC"/>
-                      </a:solidFill>
-                      <a:prstDash val="solid"/>
-                      <a:round/>
-                      <a:headEnd type="none" w="sm" len="sm"/>
-                      <a:tailEnd type="none" w="sm" len="sm"/>
-                    </a:lnT>
-                    <a:lnB w="9525" cap="flat" cmpd="sng">
-                      <a:solidFill>
-                        <a:srgbClr val="CCCCCC"/>
-                      </a:solidFill>
-                      <a:prstDash val="solid"/>
-                      <a:round/>
-                      <a:headEnd type="none" w="sm" len="sm"/>
-                      <a:tailEnd type="none" w="sm" len="sm"/>
-                    </a:lnB>
-                  </a:tcPr>
-                </a:tc>
-                <a:tc>
-                  <a:txBody>
-                    <a:bodyPr/>
-                    <a:lstStyle/>
-                    <a:p>
-                      <a:pPr marL="0" lvl="0" indent="0" algn="l" rtl="0">
-                        <a:lnSpc>
-                          <a:spcPct val="115000"/>
-                        </a:lnSpc>
-                        <a:spcBef>
-                          <a:spcPts val="0"/>
-                        </a:spcBef>
-                        <a:spcAft>
-                          <a:spcPts val="0"/>
-                        </a:spcAft>
-                        <a:buNone/>
-                      </a:pPr>
-                      <a:r>
-                        <a:rPr lang="es-CL" sz="1000"/>
-                        <a:t>Dado que el usuario/sistema cumple las condiciones descritas, cuando se ejecute la función, entonces el sistema deberá mostrar cómo cambian las mediciones del usuario entre evaluaciones, por ejemplo peso o presión, cumpliendo el requerimiento funcional.</a:t>
-                      </a:r>
-                      <a:endParaRPr sz="1000"/>
-                    </a:p>
-                  </a:txBody>
-                  <a:tcPr marL="28575" marR="28575" marT="91425" marB="91425">
-                    <a:lnL w="9525" cap="flat" cmpd="sng">
-                      <a:solidFill>
-                        <a:srgbClr val="CCCCCC"/>
-                      </a:solidFill>
-                      <a:prstDash val="solid"/>
-                      <a:round/>
-                      <a:headEnd type="none" w="sm" len="sm"/>
-                      <a:tailEnd type="none" w="sm" len="sm"/>
-                    </a:lnL>
-                    <a:lnR w="9525" cap="flat" cmpd="sng">
-                      <a:solidFill>
-                        <a:srgbClr val="CCCCCC"/>
-                      </a:solidFill>
-                      <a:prstDash val="solid"/>
-                      <a:round/>
-                      <a:headEnd type="none" w="sm" len="sm"/>
-                      <a:tailEnd type="none" w="sm" len="sm"/>
-                    </a:lnR>
-                    <a:lnT w="9525" cap="flat" cmpd="sng">
-                      <a:solidFill>
-                        <a:srgbClr val="CCCCCC"/>
-                      </a:solidFill>
-                      <a:prstDash val="solid"/>
-                      <a:round/>
-                      <a:headEnd type="none" w="sm" len="sm"/>
-                      <a:tailEnd type="none" w="sm" len="sm"/>
-                    </a:lnT>
-                    <a:lnB w="9525" cap="flat" cmpd="sng">
-                      <a:solidFill>
-                        <a:srgbClr val="CCCCCC"/>
-                      </a:solidFill>
-                      <a:prstDash val="solid"/>
-                      <a:round/>
-                      <a:headEnd type="none" w="sm" len="sm"/>
-                      <a:tailEnd type="none" w="sm" len="sm"/>
-                    </a:lnB>
-                  </a:tcPr>
-                </a:tc>
-                <a:tc>
-                  <a:txBody>
-                    <a:bodyPr/>
-                    <a:lstStyle/>
-                    <a:p>
-                      <a:pPr marL="0" lvl="0" indent="0" algn="l" rtl="0">
-                        <a:lnSpc>
-                          <a:spcPct val="115000"/>
-                        </a:lnSpc>
-                        <a:spcBef>
-                          <a:spcPts val="0"/>
-                        </a:spcBef>
-                        <a:spcAft>
-                          <a:spcPts val="0"/>
-                        </a:spcAft>
-                        <a:buNone/>
-                      </a:pPr>
-                      <a:r>
-                        <a:rPr lang="es-CL" sz="1000"/>
-                        <a:t>Must have</a:t>
-                      </a:r>
-                      <a:endParaRPr sz="1000"/>
-                    </a:p>
-                  </a:txBody>
-                  <a:tcPr marL="28575" marR="28575" marT="91425" marB="91425">
-                    <a:lnL w="9525" cap="flat" cmpd="sng">
-                      <a:solidFill>
-                        <a:srgbClr val="CCCCCC"/>
-                      </a:solidFill>
-                      <a:prstDash val="solid"/>
-                      <a:round/>
-                      <a:headEnd type="none" w="sm" len="sm"/>
-                      <a:tailEnd type="none" w="sm" len="sm"/>
-                    </a:lnL>
-                    <a:lnR w="9525" cap="flat" cmpd="sng">
-                      <a:solidFill>
-                        <a:srgbClr val="CCCCCC"/>
-                      </a:solidFill>
-                      <a:prstDash val="solid"/>
-                      <a:round/>
-                      <a:headEnd type="none" w="sm" len="sm"/>
-                      <a:tailEnd type="none" w="sm" len="sm"/>
-                    </a:lnR>
-                    <a:lnT w="9525" cap="flat" cmpd="sng">
-                      <a:solidFill>
-                        <a:srgbClr val="CCCCCC"/>
-                      </a:solidFill>
-                      <a:prstDash val="solid"/>
-                      <a:round/>
-                      <a:headEnd type="none" w="sm" len="sm"/>
-                      <a:tailEnd type="none" w="sm" len="sm"/>
-                    </a:lnT>
-                    <a:lnB w="9525" cap="flat" cmpd="sng">
-                      <a:solidFill>
-                        <a:srgbClr val="CCCCCC"/>
-                      </a:solidFill>
-                      <a:prstDash val="solid"/>
-                      <a:round/>
-                      <a:headEnd type="none" w="sm" len="sm"/>
-                      <a:tailEnd type="none" w="sm" len="sm"/>
-                    </a:lnB>
-                    <a:solidFill>
-                      <a:srgbClr val="C6EFCE"/>
-                    </a:solidFill>
-                  </a:tcPr>
-                </a:tc>
-                <a:tc>
-                  <a:txBody>
-                    <a:bodyPr/>
-                    <a:lstStyle/>
-                    <a:p>
-                      <a:pPr marL="0" lvl="0" indent="0" algn="r" rtl="0">
-                        <a:lnSpc>
-                          <a:spcPct val="115000"/>
-                        </a:lnSpc>
-                        <a:spcBef>
-                          <a:spcPts val="0"/>
-                        </a:spcBef>
-                        <a:spcAft>
-                          <a:spcPts val="0"/>
-                        </a:spcAft>
-                        <a:buNone/>
-                      </a:pPr>
-                      <a:r>
-                        <a:rPr lang="es-CL" sz="1000"/>
-                        <a:t>5</a:t>
-                      </a:r>
-                      <a:endParaRPr sz="1000"/>
-                    </a:p>
-                  </a:txBody>
-                  <a:tcPr marL="28575" marR="28575" marT="91425" marB="91425">
-                    <a:lnL w="9525" cap="flat" cmpd="sng">
-                      <a:solidFill>
-                        <a:srgbClr val="CCCCCC"/>
-                      </a:solidFill>
-                      <a:prstDash val="solid"/>
-                      <a:round/>
-                      <a:headEnd type="none" w="sm" len="sm"/>
-                      <a:tailEnd type="none" w="sm" len="sm"/>
-                    </a:lnL>
-                    <a:lnR w="9525" cap="flat" cmpd="sng">
-                      <a:solidFill>
-                        <a:srgbClr val="CCCCCC"/>
-                      </a:solidFill>
-                      <a:prstDash val="solid"/>
-                      <a:round/>
-                      <a:headEnd type="none" w="sm" len="sm"/>
-                      <a:tailEnd type="none" w="sm" len="sm"/>
-                    </a:lnR>
-                    <a:lnT w="9525" cap="flat" cmpd="sng">
-                      <a:solidFill>
-                        <a:srgbClr val="CCCCCC"/>
-                      </a:solidFill>
-                      <a:prstDash val="solid"/>
-                      <a:round/>
-                      <a:headEnd type="none" w="sm" len="sm"/>
-                      <a:tailEnd type="none" w="sm" len="sm"/>
-                    </a:lnT>
-                    <a:lnB w="9525" cap="flat" cmpd="sng">
-                      <a:solidFill>
-                        <a:srgbClr val="CCCCCC"/>
-                      </a:solidFill>
-                      <a:prstDash val="solid"/>
-                      <a:round/>
-                      <a:headEnd type="none" w="sm" len="sm"/>
-                      <a:tailEnd type="none" w="sm" len="sm"/>
-                    </a:lnB>
-                  </a:tcPr>
-                </a:tc>
-                <a:tc>
-                  <a:txBody>
-                    <a:bodyPr/>
-                    <a:lstStyle/>
-                    <a:p>
-                      <a:pPr marL="0" lvl="0" indent="0" algn="l" rtl="0">
-                        <a:lnSpc>
-                          <a:spcPct val="115000"/>
-                        </a:lnSpc>
-                        <a:spcBef>
-                          <a:spcPts val="0"/>
-                        </a:spcBef>
-                        <a:spcAft>
-                          <a:spcPts val="0"/>
-                        </a:spcAft>
-                        <a:buNone/>
-                      </a:pPr>
-                      <a:r>
-                        <a:rPr lang="es-CL" sz="1000"/>
-                        <a:t>Sprint 5</a:t>
-                      </a:r>
-                      <a:endParaRPr sz="1000"/>
-                    </a:p>
-                  </a:txBody>
-                  <a:tcPr marL="28575" marR="28575" marT="91425" marB="91425">
-                    <a:lnL w="9525" cap="flat" cmpd="sng">
-                      <a:solidFill>
-                        <a:srgbClr val="CCCCCC"/>
-                      </a:solidFill>
-                      <a:prstDash val="solid"/>
-                      <a:round/>
-                      <a:headEnd type="none" w="sm" len="sm"/>
-                      <a:tailEnd type="none" w="sm" len="sm"/>
-                    </a:lnL>
-                    <a:lnR w="9525" cap="flat" cmpd="sng">
-                      <a:solidFill>
-                        <a:srgbClr val="CCCCCC"/>
-                      </a:solidFill>
-                      <a:prstDash val="solid"/>
-                      <a:round/>
-                      <a:headEnd type="none" w="sm" len="sm"/>
-                      <a:tailEnd type="none" w="sm" len="sm"/>
-                    </a:lnR>
-                    <a:lnT w="9525" cap="flat" cmpd="sng">
-                      <a:solidFill>
-                        <a:srgbClr val="CCCCCC"/>
-                      </a:solidFill>
-                      <a:prstDash val="solid"/>
-                      <a:round/>
-                      <a:headEnd type="none" w="sm" len="sm"/>
-                      <a:tailEnd type="none" w="sm" len="sm"/>
-                    </a:lnT>
-                    <a:lnB w="9525" cap="flat" cmpd="sng">
-                      <a:solidFill>
-                        <a:srgbClr val="CCCCCC"/>
-                      </a:solidFill>
-                      <a:prstDash val="solid"/>
-                      <a:round/>
-                      <a:headEnd type="none" w="sm" len="sm"/>
-                      <a:tailEnd type="none" w="sm" len="sm"/>
-                    </a:lnB>
-                  </a:tcPr>
-                </a:tc>
-                <a:tc>
-                  <a:txBody>
-                    <a:bodyPr/>
-                    <a:lstStyle/>
-                    <a:p>
-                      <a:pPr marL="0" lvl="0" indent="0" algn="l" rtl="0">
-                        <a:lnSpc>
-                          <a:spcPct val="115000"/>
-                        </a:lnSpc>
-                        <a:spcBef>
-                          <a:spcPts val="0"/>
-                        </a:spcBef>
-                        <a:spcAft>
-                          <a:spcPts val="0"/>
-                        </a:spcAft>
-                        <a:buNone/>
-                      </a:pPr>
-                      <a:r>
-                        <a:rPr lang="es-CL" sz="1000"/>
-                        <a:t>Pendiente</a:t>
-                      </a:r>
-                      <a:endParaRPr sz="1000"/>
-                    </a:p>
-                  </a:txBody>
-                  <a:tcPr marL="28575" marR="28575" marT="91425" marB="91425">
-                    <a:lnL w="9525" cap="flat" cmpd="sng">
-                      <a:solidFill>
-                        <a:srgbClr val="CCCCCC"/>
-                      </a:solidFill>
-                      <a:prstDash val="solid"/>
-                      <a:round/>
-                      <a:headEnd type="none" w="sm" len="sm"/>
-                      <a:tailEnd type="none" w="sm" len="sm"/>
-                    </a:lnL>
-                    <a:lnR w="9525" cap="flat" cmpd="sng">
-                      <a:solidFill>
-                        <a:srgbClr val="CCCCCC"/>
-                      </a:solidFill>
-                      <a:prstDash val="solid"/>
-                      <a:round/>
-                      <a:headEnd type="none" w="sm" len="sm"/>
-                      <a:tailEnd type="none" w="sm" len="sm"/>
-                    </a:lnR>
-                    <a:lnT w="9525" cap="flat" cmpd="sng">
-                      <a:solidFill>
-                        <a:srgbClr val="CCCCCC"/>
-                      </a:solidFill>
-                      <a:prstDash val="solid"/>
-                      <a:round/>
-                      <a:headEnd type="none" w="sm" len="sm"/>
-                      <a:tailEnd type="none" w="sm" len="sm"/>
-                    </a:lnT>
-                    <a:lnB w="9525" cap="flat" cmpd="sng">
-                      <a:solidFill>
-                        <a:srgbClr val="CCCCCC"/>
-                      </a:solidFill>
-                      <a:prstDash val="solid"/>
-                      <a:round/>
-                      <a:headEnd type="none" w="sm" len="sm"/>
-                      <a:tailEnd type="none" w="sm" len="sm"/>
-                    </a:lnB>
-                  </a:tcPr>
-                </a:tc>
-                <a:extLst>
-                  <a:ext uri="{0D108BD9-81ED-4DB2-BD59-A6C34878D82A}">
-                    <a16:rowId xmlns:a16="http://schemas.microsoft.com/office/drawing/2014/main" val="10001"/>
-                  </a:ext>
-                </a:extLst>
-              </a:tr>
-              <a:tr h="1206825">
-                <a:tc>
-                  <a:txBody>
-                    <a:bodyPr/>
-                    <a:lstStyle/>
-                    <a:p>
-                      <a:pPr marL="0" lvl="0" indent="0" algn="l" rtl="0">
-                        <a:lnSpc>
-                          <a:spcPct val="115000"/>
-                        </a:lnSpc>
-                        <a:spcBef>
-                          <a:spcPts val="0"/>
-                        </a:spcBef>
-                        <a:spcAft>
-                          <a:spcPts val="0"/>
-                        </a:spcAft>
-                        <a:buNone/>
-                      </a:pPr>
-                      <a:r>
-                        <a:rPr lang="es-CL" sz="1000"/>
-                        <a:t>R.132</a:t>
-                      </a:r>
-                      <a:endParaRPr sz="1000"/>
-                    </a:p>
-                  </a:txBody>
-                  <a:tcPr marL="28575" marR="28575" marT="91425" marB="91425">
-                    <a:lnL w="9525" cap="flat" cmpd="sng">
-                      <a:solidFill>
-                        <a:srgbClr val="CCCCCC"/>
-                      </a:solidFill>
-                      <a:prstDash val="solid"/>
-                      <a:round/>
-                      <a:headEnd type="none" w="sm" len="sm"/>
-                      <a:tailEnd type="none" w="sm" len="sm"/>
-                    </a:lnL>
-                    <a:lnR w="9525" cap="flat" cmpd="sng">
-                      <a:solidFill>
-                        <a:srgbClr val="CCCCCC"/>
-                      </a:solidFill>
-                      <a:prstDash val="solid"/>
-                      <a:round/>
-                      <a:headEnd type="none" w="sm" len="sm"/>
-                      <a:tailEnd type="none" w="sm" len="sm"/>
-                    </a:lnR>
-                    <a:lnT w="9525" cap="flat" cmpd="sng">
-                      <a:solidFill>
-                        <a:srgbClr val="CCCCCC"/>
-                      </a:solidFill>
-                      <a:prstDash val="solid"/>
-                      <a:round/>
-                      <a:headEnd type="none" w="sm" len="sm"/>
-                      <a:tailEnd type="none" w="sm" len="sm"/>
-                    </a:lnT>
-                    <a:lnB w="9525" cap="flat" cmpd="sng">
-                      <a:solidFill>
-                        <a:srgbClr val="CCCCCC"/>
-                      </a:solidFill>
-                      <a:prstDash val="solid"/>
-                      <a:round/>
-                      <a:headEnd type="none" w="sm" len="sm"/>
-                      <a:tailEnd type="none" w="sm" len="sm"/>
-                    </a:lnB>
-                  </a:tcPr>
-                </a:tc>
-                <a:tc>
-                  <a:txBody>
-                    <a:bodyPr/>
-                    <a:lstStyle/>
-                    <a:p>
-                      <a:pPr marL="0" lvl="0" indent="0" algn="l" rtl="0">
-                        <a:lnSpc>
-                          <a:spcPct val="115000"/>
-                        </a:lnSpc>
-                        <a:spcBef>
-                          <a:spcPts val="0"/>
-                        </a:spcBef>
-                        <a:spcAft>
-                          <a:spcPts val="0"/>
-                        </a:spcAft>
-                        <a:buNone/>
-                      </a:pPr>
-                      <a:r>
-                        <a:rPr lang="es-CL" sz="1000"/>
-                        <a:t>Gestión del Encargado de Gimnasio</a:t>
-                      </a:r>
-                      <a:endParaRPr sz="1000"/>
-                    </a:p>
-                  </a:txBody>
-                  <a:tcPr marL="28575" marR="28575" marT="91425" marB="91425">
-                    <a:lnL w="9525" cap="flat" cmpd="sng">
-                      <a:solidFill>
-                        <a:srgbClr val="CCCCCC"/>
-                      </a:solidFill>
-                      <a:prstDash val="solid"/>
-                      <a:round/>
-                      <a:headEnd type="none" w="sm" len="sm"/>
-                      <a:tailEnd type="none" w="sm" len="sm"/>
-                    </a:lnL>
-                    <a:lnR w="9525" cap="flat" cmpd="sng">
-                      <a:solidFill>
-                        <a:srgbClr val="CCCCCC"/>
-                      </a:solidFill>
-                      <a:prstDash val="solid"/>
-                      <a:round/>
-                      <a:headEnd type="none" w="sm" len="sm"/>
-                      <a:tailEnd type="none" w="sm" len="sm"/>
-                    </a:lnR>
-                    <a:lnT w="9525" cap="flat" cmpd="sng">
-                      <a:solidFill>
-                        <a:srgbClr val="CCCCCC"/>
-                      </a:solidFill>
-                      <a:prstDash val="solid"/>
-                      <a:round/>
-                      <a:headEnd type="none" w="sm" len="sm"/>
-                      <a:tailEnd type="none" w="sm" len="sm"/>
-                    </a:lnT>
-                    <a:lnB w="9525" cap="flat" cmpd="sng">
-                      <a:solidFill>
-                        <a:srgbClr val="CCCCCC"/>
-                      </a:solidFill>
-                      <a:prstDash val="solid"/>
-                      <a:round/>
-                      <a:headEnd type="none" w="sm" len="sm"/>
-                      <a:tailEnd type="none" w="sm" len="sm"/>
-                    </a:lnB>
-                  </a:tcPr>
-                </a:tc>
-                <a:tc>
-                  <a:txBody>
-                    <a:bodyPr/>
-                    <a:lstStyle/>
-                    <a:p>
-                      <a:pPr marL="0" lvl="0" indent="0" algn="l" rtl="0">
-                        <a:lnSpc>
-                          <a:spcPct val="115000"/>
-                        </a:lnSpc>
-                        <a:spcBef>
-                          <a:spcPts val="0"/>
-                        </a:spcBef>
-                        <a:spcAft>
-                          <a:spcPts val="0"/>
-                        </a:spcAft>
-                        <a:buNone/>
-                      </a:pPr>
-                      <a:r>
-                        <a:rPr lang="es-CL" sz="1000"/>
-                        <a:t>Como encargado del gimnasio, quiero permitir consultar los factores utilizados por la IA, para permitir que el personal del gimnasio supervise y valide el proceso.</a:t>
-                      </a:r>
-                      <a:endParaRPr sz="1000"/>
-                    </a:p>
-                  </a:txBody>
-                  <a:tcPr marL="28575" marR="28575" marT="91425" marB="91425">
-                    <a:lnL w="9525" cap="flat" cmpd="sng">
-                      <a:solidFill>
-                        <a:srgbClr val="CCCCCC"/>
-                      </a:solidFill>
-                      <a:prstDash val="solid"/>
-                      <a:round/>
-                      <a:headEnd type="none" w="sm" len="sm"/>
-                      <a:tailEnd type="none" w="sm" len="sm"/>
-                    </a:lnL>
-                    <a:lnR w="9525" cap="flat" cmpd="sng">
-                      <a:solidFill>
-                        <a:srgbClr val="CCCCCC"/>
-                      </a:solidFill>
-                      <a:prstDash val="solid"/>
-                      <a:round/>
-                      <a:headEnd type="none" w="sm" len="sm"/>
-                      <a:tailEnd type="none" w="sm" len="sm"/>
-                    </a:lnR>
-                    <a:lnT w="9525" cap="flat" cmpd="sng">
-                      <a:solidFill>
-                        <a:srgbClr val="CCCCCC"/>
-                      </a:solidFill>
-                      <a:prstDash val="solid"/>
-                      <a:round/>
-                      <a:headEnd type="none" w="sm" len="sm"/>
-                      <a:tailEnd type="none" w="sm" len="sm"/>
-                    </a:lnT>
-                    <a:lnB w="9525" cap="flat" cmpd="sng">
-                      <a:solidFill>
-                        <a:srgbClr val="CCCCCC"/>
-                      </a:solidFill>
-                      <a:prstDash val="solid"/>
-                      <a:round/>
-                      <a:headEnd type="none" w="sm" len="sm"/>
-                      <a:tailEnd type="none" w="sm" len="sm"/>
-                    </a:lnB>
-                  </a:tcPr>
-                </a:tc>
-                <a:tc>
-                  <a:txBody>
-                    <a:bodyPr/>
-                    <a:lstStyle/>
-                    <a:p>
-                      <a:pPr marL="0" lvl="0" indent="0" algn="l" rtl="0">
-                        <a:lnSpc>
-                          <a:spcPct val="115000"/>
-                        </a:lnSpc>
-                        <a:spcBef>
-                          <a:spcPts val="0"/>
-                        </a:spcBef>
-                        <a:spcAft>
-                          <a:spcPts val="0"/>
-                        </a:spcAft>
-                        <a:buNone/>
-                      </a:pPr>
-                      <a:r>
-                        <a:rPr lang="es-CL" sz="1000"/>
-                        <a:t>Funcional</a:t>
-                      </a:r>
-                      <a:endParaRPr sz="1000"/>
-                    </a:p>
-                  </a:txBody>
-                  <a:tcPr marL="28575" marR="28575" marT="91425" marB="91425">
-                    <a:lnL w="9525" cap="flat" cmpd="sng">
-                      <a:solidFill>
-                        <a:srgbClr val="CCCCCC"/>
-                      </a:solidFill>
-                      <a:prstDash val="solid"/>
-                      <a:round/>
-                      <a:headEnd type="none" w="sm" len="sm"/>
-                      <a:tailEnd type="none" w="sm" len="sm"/>
-                    </a:lnL>
-                    <a:lnR w="9525" cap="flat" cmpd="sng">
-                      <a:solidFill>
-                        <a:srgbClr val="CCCCCC"/>
-                      </a:solidFill>
-                      <a:prstDash val="solid"/>
-                      <a:round/>
-                      <a:headEnd type="none" w="sm" len="sm"/>
-                      <a:tailEnd type="none" w="sm" len="sm"/>
-                    </a:lnR>
-                    <a:lnT w="9525" cap="flat" cmpd="sng">
-                      <a:solidFill>
-                        <a:srgbClr val="CCCCCC"/>
-                      </a:solidFill>
-                      <a:prstDash val="solid"/>
-                      <a:round/>
-                      <a:headEnd type="none" w="sm" len="sm"/>
-                      <a:tailEnd type="none" w="sm" len="sm"/>
-                    </a:lnT>
-                    <a:lnB w="9525" cap="flat" cmpd="sng">
-                      <a:solidFill>
-                        <a:srgbClr val="CCCCCC"/>
-                      </a:solidFill>
-                      <a:prstDash val="solid"/>
-                      <a:round/>
-                      <a:headEnd type="none" w="sm" len="sm"/>
-                      <a:tailEnd type="none" w="sm" len="sm"/>
-                    </a:lnB>
-                  </a:tcPr>
-                </a:tc>
-                <a:tc>
-                  <a:txBody>
-                    <a:bodyPr/>
-                    <a:lstStyle/>
-                    <a:p>
-                      <a:pPr marL="0" lvl="0" indent="0" algn="l" rtl="0">
-                        <a:lnSpc>
-                          <a:spcPct val="115000"/>
-                        </a:lnSpc>
-                        <a:spcBef>
-                          <a:spcPts val="0"/>
-                        </a:spcBef>
-                        <a:spcAft>
-                          <a:spcPts val="0"/>
-                        </a:spcAft>
-                        <a:buNone/>
-                      </a:pPr>
-                      <a:r>
-                        <a:rPr lang="es-CL" sz="1000"/>
-                        <a:t>Encargado del gimnasio</a:t>
-                      </a:r>
-                      <a:endParaRPr sz="1000"/>
-                    </a:p>
-                  </a:txBody>
-                  <a:tcPr marL="28575" marR="28575" marT="91425" marB="91425">
-                    <a:lnL w="9525" cap="flat" cmpd="sng">
-                      <a:solidFill>
-                        <a:srgbClr val="CCCCCC"/>
-                      </a:solidFill>
-                      <a:prstDash val="solid"/>
-                      <a:round/>
-                      <a:headEnd type="none" w="sm" len="sm"/>
-                      <a:tailEnd type="none" w="sm" len="sm"/>
-                    </a:lnL>
-                    <a:lnR w="9525" cap="flat" cmpd="sng">
-                      <a:solidFill>
-                        <a:srgbClr val="CCCCCC"/>
-                      </a:solidFill>
-                      <a:prstDash val="solid"/>
-                      <a:round/>
-                      <a:headEnd type="none" w="sm" len="sm"/>
-                      <a:tailEnd type="none" w="sm" len="sm"/>
-                    </a:lnR>
-                    <a:lnT w="9525" cap="flat" cmpd="sng">
-                      <a:solidFill>
-                        <a:srgbClr val="CCCCCC"/>
-                      </a:solidFill>
-                      <a:prstDash val="solid"/>
-                      <a:round/>
-                      <a:headEnd type="none" w="sm" len="sm"/>
-                      <a:tailEnd type="none" w="sm" len="sm"/>
-                    </a:lnT>
-                    <a:lnB w="9525" cap="flat" cmpd="sng">
-                      <a:solidFill>
-                        <a:srgbClr val="CCCCCC"/>
-                      </a:solidFill>
-                      <a:prstDash val="solid"/>
-                      <a:round/>
-                      <a:headEnd type="none" w="sm" len="sm"/>
-                      <a:tailEnd type="none" w="sm" len="sm"/>
-                    </a:lnB>
-                  </a:tcPr>
-                </a:tc>
-                <a:tc>
-                  <a:txBody>
-                    <a:bodyPr/>
-                    <a:lstStyle/>
-                    <a:p>
-                      <a:pPr marL="0" lvl="0" indent="0" algn="l" rtl="0">
-                        <a:lnSpc>
-                          <a:spcPct val="115000"/>
-                        </a:lnSpc>
-                        <a:spcBef>
-                          <a:spcPts val="0"/>
-                        </a:spcBef>
-                        <a:spcAft>
-                          <a:spcPts val="0"/>
-                        </a:spcAft>
-                        <a:buNone/>
-                      </a:pPr>
-                      <a:r>
-                        <a:rPr lang="es-CL" sz="1000"/>
-                        <a:t>Dado que el usuario/sistema cumple las condiciones descritas, cuando se ejecute la función, entonces el sistema deberá permitir consultar los factores utilizados por la IA, cumpliendo el requerimiento funcional.</a:t>
-                      </a:r>
-                      <a:endParaRPr sz="1000"/>
-                    </a:p>
-                  </a:txBody>
-                  <a:tcPr marL="28575" marR="28575" marT="91425" marB="91425">
-                    <a:lnL w="9525" cap="flat" cmpd="sng">
-                      <a:solidFill>
-                        <a:srgbClr val="CCCCCC"/>
-                      </a:solidFill>
-                      <a:prstDash val="solid"/>
-                      <a:round/>
-                      <a:headEnd type="none" w="sm" len="sm"/>
-                      <a:tailEnd type="none" w="sm" len="sm"/>
-                    </a:lnL>
-                    <a:lnR w="9525" cap="flat" cmpd="sng">
-                      <a:solidFill>
-                        <a:srgbClr val="CCCCCC"/>
-                      </a:solidFill>
-                      <a:prstDash val="solid"/>
-                      <a:round/>
-                      <a:headEnd type="none" w="sm" len="sm"/>
-                      <a:tailEnd type="none" w="sm" len="sm"/>
-                    </a:lnR>
-                    <a:lnT w="9525" cap="flat" cmpd="sng">
-                      <a:solidFill>
-                        <a:srgbClr val="CCCCCC"/>
-                      </a:solidFill>
-                      <a:prstDash val="solid"/>
-                      <a:round/>
-                      <a:headEnd type="none" w="sm" len="sm"/>
-                      <a:tailEnd type="none" w="sm" len="sm"/>
-                    </a:lnT>
-                    <a:lnB w="9525" cap="flat" cmpd="sng">
-                      <a:solidFill>
-                        <a:srgbClr val="CCCCCC"/>
-                      </a:solidFill>
-                      <a:prstDash val="solid"/>
-                      <a:round/>
-                      <a:headEnd type="none" w="sm" len="sm"/>
-                      <a:tailEnd type="none" w="sm" len="sm"/>
-                    </a:lnB>
-                  </a:tcPr>
-                </a:tc>
-                <a:tc>
-                  <a:txBody>
-                    <a:bodyPr/>
-                    <a:lstStyle/>
-                    <a:p>
-                      <a:pPr marL="0" lvl="0" indent="0" algn="l" rtl="0">
-                        <a:lnSpc>
-                          <a:spcPct val="115000"/>
-                        </a:lnSpc>
-                        <a:spcBef>
-                          <a:spcPts val="0"/>
-                        </a:spcBef>
-                        <a:spcAft>
-                          <a:spcPts val="0"/>
-                        </a:spcAft>
-                        <a:buNone/>
-                      </a:pPr>
-                      <a:r>
-                        <a:rPr lang="es-CL" sz="1000"/>
-                        <a:t>Must have</a:t>
-                      </a:r>
-                      <a:endParaRPr sz="1000"/>
-                    </a:p>
-                  </a:txBody>
-                  <a:tcPr marL="28575" marR="28575" marT="91425" marB="91425">
-                    <a:lnL w="9525" cap="flat" cmpd="sng">
-                      <a:solidFill>
-                        <a:srgbClr val="CCCCCC"/>
-                      </a:solidFill>
-                      <a:prstDash val="solid"/>
-                      <a:round/>
-                      <a:headEnd type="none" w="sm" len="sm"/>
-                      <a:tailEnd type="none" w="sm" len="sm"/>
-                    </a:lnL>
-                    <a:lnR w="9525" cap="flat" cmpd="sng">
-                      <a:solidFill>
-                        <a:srgbClr val="CCCCCC"/>
-                      </a:solidFill>
-                      <a:prstDash val="solid"/>
-                      <a:round/>
-                      <a:headEnd type="none" w="sm" len="sm"/>
-                      <a:tailEnd type="none" w="sm" len="sm"/>
-                    </a:lnR>
-                    <a:lnT w="9525" cap="flat" cmpd="sng">
-                      <a:solidFill>
-                        <a:srgbClr val="CCCCCC"/>
-                      </a:solidFill>
-                      <a:prstDash val="solid"/>
-                      <a:round/>
-                      <a:headEnd type="none" w="sm" len="sm"/>
-                      <a:tailEnd type="none" w="sm" len="sm"/>
-                    </a:lnT>
-                    <a:lnB w="9525" cap="flat" cmpd="sng">
-                      <a:solidFill>
-                        <a:srgbClr val="CCCCCC"/>
-                      </a:solidFill>
-                      <a:prstDash val="solid"/>
-                      <a:round/>
-                      <a:headEnd type="none" w="sm" len="sm"/>
-                      <a:tailEnd type="none" w="sm" len="sm"/>
-                    </a:lnB>
-                    <a:solidFill>
-                      <a:srgbClr val="C6EFCE"/>
-                    </a:solidFill>
-                  </a:tcPr>
-                </a:tc>
-                <a:tc>
-                  <a:txBody>
-                    <a:bodyPr/>
-                    <a:lstStyle/>
-                    <a:p>
-                      <a:pPr marL="0" lvl="0" indent="0" algn="r" rtl="0">
-                        <a:lnSpc>
-                          <a:spcPct val="115000"/>
-                        </a:lnSpc>
-                        <a:spcBef>
-                          <a:spcPts val="0"/>
-                        </a:spcBef>
-                        <a:spcAft>
-                          <a:spcPts val="0"/>
-                        </a:spcAft>
-                        <a:buNone/>
-                      </a:pPr>
-                      <a:r>
-                        <a:rPr lang="es-CL" sz="1000"/>
-                        <a:t>3</a:t>
-                      </a:r>
-                      <a:endParaRPr sz="1000"/>
-                    </a:p>
-                  </a:txBody>
-                  <a:tcPr marL="28575" marR="28575" marT="91425" marB="91425">
-                    <a:lnL w="9525" cap="flat" cmpd="sng">
-                      <a:solidFill>
-                        <a:srgbClr val="CCCCCC"/>
-                      </a:solidFill>
-                      <a:prstDash val="solid"/>
-                      <a:round/>
-                      <a:headEnd type="none" w="sm" len="sm"/>
-                      <a:tailEnd type="none" w="sm" len="sm"/>
-                    </a:lnL>
-                    <a:lnR w="9525" cap="flat" cmpd="sng">
-                      <a:solidFill>
-                        <a:srgbClr val="CCCCCC"/>
-                      </a:solidFill>
-                      <a:prstDash val="solid"/>
-                      <a:round/>
-                      <a:headEnd type="none" w="sm" len="sm"/>
-                      <a:tailEnd type="none" w="sm" len="sm"/>
-                    </a:lnR>
-                    <a:lnT w="9525" cap="flat" cmpd="sng">
-                      <a:solidFill>
-                        <a:srgbClr val="CCCCCC"/>
-                      </a:solidFill>
-                      <a:prstDash val="solid"/>
-                      <a:round/>
-                      <a:headEnd type="none" w="sm" len="sm"/>
-                      <a:tailEnd type="none" w="sm" len="sm"/>
-                    </a:lnT>
-                    <a:lnB w="9525" cap="flat" cmpd="sng">
-                      <a:solidFill>
-                        <a:srgbClr val="CCCCCC"/>
-                      </a:solidFill>
-                      <a:prstDash val="solid"/>
-                      <a:round/>
-                      <a:headEnd type="none" w="sm" len="sm"/>
-                      <a:tailEnd type="none" w="sm" len="sm"/>
-                    </a:lnB>
-                  </a:tcPr>
-                </a:tc>
-                <a:tc>
-                  <a:txBody>
-                    <a:bodyPr/>
-                    <a:lstStyle/>
-                    <a:p>
-                      <a:pPr marL="0" lvl="0" indent="0" algn="l" rtl="0">
-                        <a:lnSpc>
-                          <a:spcPct val="115000"/>
-                        </a:lnSpc>
-                        <a:spcBef>
-                          <a:spcPts val="0"/>
-                        </a:spcBef>
-                        <a:spcAft>
-                          <a:spcPts val="0"/>
-                        </a:spcAft>
-                        <a:buNone/>
-                      </a:pPr>
-                      <a:r>
-                        <a:rPr lang="es-CL" sz="1000"/>
-                        <a:t>Sprint 5</a:t>
-                      </a:r>
-                      <a:endParaRPr sz="1000"/>
-                    </a:p>
-                  </a:txBody>
-                  <a:tcPr marL="28575" marR="28575" marT="91425" marB="91425">
-                    <a:lnL w="9525" cap="flat" cmpd="sng">
-                      <a:solidFill>
-                        <a:srgbClr val="CCCCCC"/>
-                      </a:solidFill>
-                      <a:prstDash val="solid"/>
-                      <a:round/>
-                      <a:headEnd type="none" w="sm" len="sm"/>
-                      <a:tailEnd type="none" w="sm" len="sm"/>
-                    </a:lnL>
-                    <a:lnR w="9525" cap="flat" cmpd="sng">
-                      <a:solidFill>
-                        <a:srgbClr val="CCCCCC"/>
-                      </a:solidFill>
-                      <a:prstDash val="solid"/>
-                      <a:round/>
-                      <a:headEnd type="none" w="sm" len="sm"/>
-                      <a:tailEnd type="none" w="sm" len="sm"/>
-                    </a:lnR>
-                    <a:lnT w="9525" cap="flat" cmpd="sng">
-                      <a:solidFill>
-                        <a:srgbClr val="CCCCCC"/>
-                      </a:solidFill>
-                      <a:prstDash val="solid"/>
-                      <a:round/>
-                      <a:headEnd type="none" w="sm" len="sm"/>
-                      <a:tailEnd type="none" w="sm" len="sm"/>
-                    </a:lnT>
-                    <a:lnB w="9525" cap="flat" cmpd="sng">
-                      <a:solidFill>
-                        <a:srgbClr val="CCCCCC"/>
-                      </a:solidFill>
-                      <a:prstDash val="solid"/>
-                      <a:round/>
-                      <a:headEnd type="none" w="sm" len="sm"/>
-                      <a:tailEnd type="none" w="sm" len="sm"/>
-                    </a:lnB>
-                  </a:tcPr>
-                </a:tc>
-                <a:tc>
-                  <a:txBody>
-                    <a:bodyPr/>
-                    <a:lstStyle/>
-                    <a:p>
-                      <a:pPr marL="0" lvl="0" indent="0" algn="l" rtl="0">
-                        <a:lnSpc>
-                          <a:spcPct val="115000"/>
-                        </a:lnSpc>
-                        <a:spcBef>
-                          <a:spcPts val="0"/>
-                        </a:spcBef>
-                        <a:spcAft>
-                          <a:spcPts val="0"/>
-                        </a:spcAft>
-                        <a:buNone/>
-                      </a:pPr>
-                      <a:r>
-                        <a:rPr lang="es-CL" sz="1000"/>
-                        <a:t>Pendiente</a:t>
-                      </a:r>
-                      <a:endParaRPr sz="1000"/>
-                    </a:p>
-                  </a:txBody>
-                  <a:tcPr marL="28575" marR="28575" marT="91425" marB="91425">
-                    <a:lnL w="9525" cap="flat" cmpd="sng">
-                      <a:solidFill>
-                        <a:srgbClr val="CCCCCC"/>
-                      </a:solidFill>
-                      <a:prstDash val="solid"/>
-                      <a:round/>
-                      <a:headEnd type="none" w="sm" len="sm"/>
-                      <a:tailEnd type="none" w="sm" len="sm"/>
-                    </a:lnL>
-                    <a:lnR w="9525" cap="flat" cmpd="sng">
-                      <a:solidFill>
-                        <a:srgbClr val="CCCCCC"/>
-                      </a:solidFill>
-                      <a:prstDash val="solid"/>
-                      <a:round/>
-                      <a:headEnd type="none" w="sm" len="sm"/>
-                      <a:tailEnd type="none" w="sm" len="sm"/>
-                    </a:lnR>
-                    <a:lnT w="9525" cap="flat" cmpd="sng">
-                      <a:solidFill>
-                        <a:srgbClr val="CCCCCC"/>
-                      </a:solidFill>
-                      <a:prstDash val="solid"/>
-                      <a:round/>
-                      <a:headEnd type="none" w="sm" len="sm"/>
-                      <a:tailEnd type="none" w="sm" len="sm"/>
-                    </a:lnT>
-                    <a:lnB w="9525" cap="flat" cmpd="sng">
-                      <a:solidFill>
-                        <a:srgbClr val="CCCCCC"/>
-                      </a:solidFill>
-                      <a:prstDash val="solid"/>
-                      <a:round/>
-                      <a:headEnd type="none" w="sm" len="sm"/>
-                      <a:tailEnd type="none" w="sm" len="sm"/>
-                    </a:lnB>
-                  </a:tcPr>
-                </a:tc>
-                <a:extLst>
-                  <a:ext uri="{0D108BD9-81ED-4DB2-BD59-A6C34878D82A}">
-                    <a16:rowId xmlns:a16="http://schemas.microsoft.com/office/drawing/2014/main" val="10002"/>
-                  </a:ext>
-                </a:extLst>
-              </a:tr>
-              <a:tr h="1206825">
-                <a:tc>
-                  <a:txBody>
-                    <a:bodyPr/>
-                    <a:lstStyle/>
-                    <a:p>
-                      <a:pPr marL="0" lvl="0" indent="0" algn="l" rtl="0">
-                        <a:lnSpc>
-                          <a:spcPct val="115000"/>
-                        </a:lnSpc>
-                        <a:spcBef>
-                          <a:spcPts val="0"/>
-                        </a:spcBef>
-                        <a:spcAft>
-                          <a:spcPts val="0"/>
-                        </a:spcAft>
-                        <a:buNone/>
-                      </a:pPr>
-                      <a:r>
-                        <a:rPr lang="es-CL" sz="1000"/>
-                        <a:t>R.133</a:t>
-                      </a:r>
-                      <a:endParaRPr sz="1000"/>
-                    </a:p>
-                  </a:txBody>
-                  <a:tcPr marL="28575" marR="28575" marT="91425" marB="91425">
-                    <a:lnL w="9525" cap="flat" cmpd="sng">
-                      <a:solidFill>
-                        <a:srgbClr val="CCCCCC"/>
-                      </a:solidFill>
-                      <a:prstDash val="solid"/>
-                      <a:round/>
-                      <a:headEnd type="none" w="sm" len="sm"/>
-                      <a:tailEnd type="none" w="sm" len="sm"/>
-                    </a:lnL>
-                    <a:lnR w="9525" cap="flat" cmpd="sng">
-                      <a:solidFill>
-                        <a:srgbClr val="CCCCCC"/>
-                      </a:solidFill>
-                      <a:prstDash val="solid"/>
-                      <a:round/>
-                      <a:headEnd type="none" w="sm" len="sm"/>
-                      <a:tailEnd type="none" w="sm" len="sm"/>
-                    </a:lnR>
-                    <a:lnT w="9525" cap="flat" cmpd="sng">
-                      <a:solidFill>
-                        <a:srgbClr val="CCCCCC"/>
-                      </a:solidFill>
-                      <a:prstDash val="solid"/>
-                      <a:round/>
-                      <a:headEnd type="none" w="sm" len="sm"/>
-                      <a:tailEnd type="none" w="sm" len="sm"/>
-                    </a:lnT>
-                    <a:lnB w="9525" cap="flat" cmpd="sng">
-                      <a:solidFill>
-                        <a:srgbClr val="CCCCCC"/>
-                      </a:solidFill>
-                      <a:prstDash val="solid"/>
-                      <a:round/>
-                      <a:headEnd type="none" w="sm" len="sm"/>
-                      <a:tailEnd type="none" w="sm" len="sm"/>
-                    </a:lnB>
-                  </a:tcPr>
-                </a:tc>
-                <a:tc>
-                  <a:txBody>
-                    <a:bodyPr/>
-                    <a:lstStyle/>
-                    <a:p>
-                      <a:pPr marL="0" lvl="0" indent="0" algn="l" rtl="0">
-                        <a:lnSpc>
-                          <a:spcPct val="115000"/>
-                        </a:lnSpc>
-                        <a:spcBef>
-                          <a:spcPts val="0"/>
-                        </a:spcBef>
-                        <a:spcAft>
-                          <a:spcPts val="0"/>
-                        </a:spcAft>
-                        <a:buNone/>
-                      </a:pPr>
-                      <a:r>
-                        <a:rPr lang="es-CL" sz="1000"/>
-                        <a:t>Gestión del Encargado de Gimnasio</a:t>
-                      </a:r>
-                      <a:endParaRPr sz="1000"/>
-                    </a:p>
-                  </a:txBody>
-                  <a:tcPr marL="28575" marR="28575" marT="91425" marB="91425">
-                    <a:lnL w="9525" cap="flat" cmpd="sng">
-                      <a:solidFill>
-                        <a:srgbClr val="CCCCCC"/>
-                      </a:solidFill>
-                      <a:prstDash val="solid"/>
-                      <a:round/>
-                      <a:headEnd type="none" w="sm" len="sm"/>
-                      <a:tailEnd type="none" w="sm" len="sm"/>
-                    </a:lnL>
-                    <a:lnR w="9525" cap="flat" cmpd="sng">
-                      <a:solidFill>
-                        <a:srgbClr val="CCCCCC"/>
-                      </a:solidFill>
-                      <a:prstDash val="solid"/>
-                      <a:round/>
-                      <a:headEnd type="none" w="sm" len="sm"/>
-                      <a:tailEnd type="none" w="sm" len="sm"/>
-                    </a:lnR>
-                    <a:lnT w="9525" cap="flat" cmpd="sng">
-                      <a:solidFill>
-                        <a:srgbClr val="CCCCCC"/>
-                      </a:solidFill>
-                      <a:prstDash val="solid"/>
-                      <a:round/>
-                      <a:headEnd type="none" w="sm" len="sm"/>
-                      <a:tailEnd type="none" w="sm" len="sm"/>
-                    </a:lnT>
-                    <a:lnB w="9525" cap="flat" cmpd="sng">
-                      <a:solidFill>
-                        <a:srgbClr val="CCCCCC"/>
-                      </a:solidFill>
-                      <a:prstDash val="solid"/>
-                      <a:round/>
-                      <a:headEnd type="none" w="sm" len="sm"/>
-                      <a:tailEnd type="none" w="sm" len="sm"/>
-                    </a:lnB>
-                  </a:tcPr>
-                </a:tc>
-                <a:tc>
-                  <a:txBody>
-                    <a:bodyPr/>
-                    <a:lstStyle/>
-                    <a:p>
-                      <a:pPr marL="0" lvl="0" indent="0" algn="l" rtl="0">
-                        <a:lnSpc>
-                          <a:spcPct val="115000"/>
-                        </a:lnSpc>
-                        <a:spcBef>
-                          <a:spcPts val="0"/>
-                        </a:spcBef>
-                        <a:spcAft>
-                          <a:spcPts val="0"/>
-                        </a:spcAft>
-                        <a:buNone/>
-                      </a:pPr>
-                      <a:r>
-                        <a:rPr lang="es-CL" sz="1000"/>
-                        <a:t>Como encargado del gimnasio, quiero registrar la confirmación hecha por el encargado, para permitir que el personal del gimnasio supervise y valide el proceso.</a:t>
-                      </a:r>
-                      <a:endParaRPr sz="1000"/>
-                    </a:p>
-                  </a:txBody>
-                  <a:tcPr marL="28575" marR="28575" marT="91425" marB="91425">
-                    <a:lnL w="9525" cap="flat" cmpd="sng">
-                      <a:solidFill>
-                        <a:srgbClr val="CCCCCC"/>
-                      </a:solidFill>
-                      <a:prstDash val="solid"/>
-                      <a:round/>
-                      <a:headEnd type="none" w="sm" len="sm"/>
-                      <a:tailEnd type="none" w="sm" len="sm"/>
-                    </a:lnL>
-                    <a:lnR w="9525" cap="flat" cmpd="sng">
-                      <a:solidFill>
-                        <a:srgbClr val="CCCCCC"/>
-                      </a:solidFill>
-                      <a:prstDash val="solid"/>
-                      <a:round/>
-                      <a:headEnd type="none" w="sm" len="sm"/>
-                      <a:tailEnd type="none" w="sm" len="sm"/>
-                    </a:lnR>
-                    <a:lnT w="9525" cap="flat" cmpd="sng">
-                      <a:solidFill>
-                        <a:srgbClr val="CCCCCC"/>
-                      </a:solidFill>
-                      <a:prstDash val="solid"/>
-                      <a:round/>
-                      <a:headEnd type="none" w="sm" len="sm"/>
-                      <a:tailEnd type="none" w="sm" len="sm"/>
-                    </a:lnT>
-                    <a:lnB w="9525" cap="flat" cmpd="sng">
-                      <a:solidFill>
-                        <a:srgbClr val="CCCCCC"/>
-                      </a:solidFill>
-                      <a:prstDash val="solid"/>
-                      <a:round/>
-                      <a:headEnd type="none" w="sm" len="sm"/>
-                      <a:tailEnd type="none" w="sm" len="sm"/>
-                    </a:lnB>
-                  </a:tcPr>
-                </a:tc>
-                <a:tc>
-                  <a:txBody>
-                    <a:bodyPr/>
-                    <a:lstStyle/>
-                    <a:p>
-                      <a:pPr marL="0" lvl="0" indent="0" algn="l" rtl="0">
-                        <a:lnSpc>
-                          <a:spcPct val="115000"/>
-                        </a:lnSpc>
-                        <a:spcBef>
-                          <a:spcPts val="0"/>
-                        </a:spcBef>
-                        <a:spcAft>
-                          <a:spcPts val="0"/>
-                        </a:spcAft>
-                        <a:buNone/>
-                      </a:pPr>
-                      <a:r>
-                        <a:rPr lang="es-CL" sz="1000"/>
-                        <a:t>Funcional</a:t>
-                      </a:r>
-                      <a:endParaRPr sz="1000"/>
-                    </a:p>
-                  </a:txBody>
-                  <a:tcPr marL="28575" marR="28575" marT="91425" marB="91425">
-                    <a:lnL w="9525" cap="flat" cmpd="sng">
-                      <a:solidFill>
-                        <a:srgbClr val="CCCCCC"/>
-                      </a:solidFill>
-                      <a:prstDash val="solid"/>
-                      <a:round/>
-                      <a:headEnd type="none" w="sm" len="sm"/>
-                      <a:tailEnd type="none" w="sm" len="sm"/>
-                    </a:lnL>
-                    <a:lnR w="9525" cap="flat" cmpd="sng">
-                      <a:solidFill>
-                        <a:srgbClr val="CCCCCC"/>
-                      </a:solidFill>
-                      <a:prstDash val="solid"/>
-                      <a:round/>
-                      <a:headEnd type="none" w="sm" len="sm"/>
-                      <a:tailEnd type="none" w="sm" len="sm"/>
-                    </a:lnR>
-                    <a:lnT w="9525" cap="flat" cmpd="sng">
-                      <a:solidFill>
-                        <a:srgbClr val="CCCCCC"/>
-                      </a:solidFill>
-                      <a:prstDash val="solid"/>
-                      <a:round/>
-                      <a:headEnd type="none" w="sm" len="sm"/>
-                      <a:tailEnd type="none" w="sm" len="sm"/>
-                    </a:lnT>
-                    <a:lnB w="9525" cap="flat" cmpd="sng">
-                      <a:solidFill>
-                        <a:srgbClr val="CCCCCC"/>
-                      </a:solidFill>
-                      <a:prstDash val="solid"/>
-                      <a:round/>
-                      <a:headEnd type="none" w="sm" len="sm"/>
-                      <a:tailEnd type="none" w="sm" len="sm"/>
-                    </a:lnB>
-                  </a:tcPr>
-                </a:tc>
-                <a:tc>
-                  <a:txBody>
-                    <a:bodyPr/>
-                    <a:lstStyle/>
-                    <a:p>
-                      <a:pPr marL="0" lvl="0" indent="0" algn="l" rtl="0">
-                        <a:lnSpc>
-                          <a:spcPct val="115000"/>
-                        </a:lnSpc>
-                        <a:spcBef>
-                          <a:spcPts val="0"/>
-                        </a:spcBef>
-                        <a:spcAft>
-                          <a:spcPts val="0"/>
-                        </a:spcAft>
-                        <a:buNone/>
-                      </a:pPr>
-                      <a:r>
-                        <a:rPr lang="es-CL" sz="1000"/>
-                        <a:t>Encargado del gimnasio</a:t>
-                      </a:r>
-                      <a:endParaRPr sz="1000"/>
-                    </a:p>
-                  </a:txBody>
-                  <a:tcPr marL="28575" marR="28575" marT="91425" marB="91425">
-                    <a:lnL w="9525" cap="flat" cmpd="sng">
-                      <a:solidFill>
-                        <a:srgbClr val="CCCCCC"/>
-                      </a:solidFill>
-                      <a:prstDash val="solid"/>
-                      <a:round/>
-                      <a:headEnd type="none" w="sm" len="sm"/>
-                      <a:tailEnd type="none" w="sm" len="sm"/>
-                    </a:lnL>
-                    <a:lnR w="9525" cap="flat" cmpd="sng">
-                      <a:solidFill>
-                        <a:srgbClr val="CCCCCC"/>
-                      </a:solidFill>
-                      <a:prstDash val="solid"/>
-                      <a:round/>
-                      <a:headEnd type="none" w="sm" len="sm"/>
-                      <a:tailEnd type="none" w="sm" len="sm"/>
-                    </a:lnR>
-                    <a:lnT w="9525" cap="flat" cmpd="sng">
-                      <a:solidFill>
-                        <a:srgbClr val="CCCCCC"/>
-                      </a:solidFill>
-                      <a:prstDash val="solid"/>
-                      <a:round/>
-                      <a:headEnd type="none" w="sm" len="sm"/>
-                      <a:tailEnd type="none" w="sm" len="sm"/>
-                    </a:lnT>
-                    <a:lnB w="9525" cap="flat" cmpd="sng">
-                      <a:solidFill>
-                        <a:srgbClr val="CCCCCC"/>
-                      </a:solidFill>
-                      <a:prstDash val="solid"/>
-                      <a:round/>
-                      <a:headEnd type="none" w="sm" len="sm"/>
-                      <a:tailEnd type="none" w="sm" len="sm"/>
-                    </a:lnB>
-                  </a:tcPr>
-                </a:tc>
-                <a:tc>
-                  <a:txBody>
-                    <a:bodyPr/>
-                    <a:lstStyle/>
-                    <a:p>
-                      <a:pPr marL="0" lvl="0" indent="0" algn="l" rtl="0">
-                        <a:lnSpc>
-                          <a:spcPct val="115000"/>
-                        </a:lnSpc>
-                        <a:spcBef>
-                          <a:spcPts val="0"/>
-                        </a:spcBef>
-                        <a:spcAft>
-                          <a:spcPts val="0"/>
-                        </a:spcAft>
-                        <a:buNone/>
-                      </a:pPr>
-                      <a:r>
-                        <a:rPr lang="es-CL" sz="1000"/>
-                        <a:t>Dado que el usuario/sistema cumple las condiciones descritas, cuando se ejecute la función, entonces el sistema deberá registrar la confirmación hecha por el encargado, cumpliendo el requerimiento funcional.</a:t>
-                      </a:r>
-                      <a:endParaRPr sz="1000"/>
-                    </a:p>
-                  </a:txBody>
-                  <a:tcPr marL="28575" marR="28575" marT="91425" marB="91425">
-                    <a:lnL w="9525" cap="flat" cmpd="sng">
-                      <a:solidFill>
-                        <a:srgbClr val="CCCCCC"/>
-                      </a:solidFill>
-                      <a:prstDash val="solid"/>
-                      <a:round/>
-                      <a:headEnd type="none" w="sm" len="sm"/>
-                      <a:tailEnd type="none" w="sm" len="sm"/>
-                    </a:lnL>
-                    <a:lnR w="9525" cap="flat" cmpd="sng">
-                      <a:solidFill>
-                        <a:srgbClr val="CCCCCC"/>
-                      </a:solidFill>
-                      <a:prstDash val="solid"/>
-                      <a:round/>
-                      <a:headEnd type="none" w="sm" len="sm"/>
-                      <a:tailEnd type="none" w="sm" len="sm"/>
-                    </a:lnR>
-                    <a:lnT w="9525" cap="flat" cmpd="sng">
-                      <a:solidFill>
-                        <a:srgbClr val="CCCCCC"/>
-                      </a:solidFill>
-                      <a:prstDash val="solid"/>
-                      <a:round/>
-                      <a:headEnd type="none" w="sm" len="sm"/>
-                      <a:tailEnd type="none" w="sm" len="sm"/>
-                    </a:lnT>
-                    <a:lnB w="9525" cap="flat" cmpd="sng">
-                      <a:solidFill>
-                        <a:srgbClr val="CCCCCC"/>
-                      </a:solidFill>
-                      <a:prstDash val="solid"/>
-                      <a:round/>
-                      <a:headEnd type="none" w="sm" len="sm"/>
-                      <a:tailEnd type="none" w="sm" len="sm"/>
-                    </a:lnB>
-                  </a:tcPr>
-                </a:tc>
-                <a:tc>
-                  <a:txBody>
-                    <a:bodyPr/>
-                    <a:lstStyle/>
-                    <a:p>
-                      <a:pPr marL="0" lvl="0" indent="0" algn="l" rtl="0">
-                        <a:lnSpc>
-                          <a:spcPct val="115000"/>
-                        </a:lnSpc>
-                        <a:spcBef>
-                          <a:spcPts val="0"/>
-                        </a:spcBef>
-                        <a:spcAft>
-                          <a:spcPts val="0"/>
-                        </a:spcAft>
-                        <a:buNone/>
-                      </a:pPr>
-                      <a:r>
-                        <a:rPr lang="es-CL" sz="1000"/>
-                        <a:t>Must have</a:t>
-                      </a:r>
-                      <a:endParaRPr sz="1000"/>
-                    </a:p>
-                  </a:txBody>
-                  <a:tcPr marL="28575" marR="28575" marT="91425" marB="91425">
-                    <a:lnL w="9525" cap="flat" cmpd="sng">
-                      <a:solidFill>
-                        <a:srgbClr val="CCCCCC"/>
-                      </a:solidFill>
-                      <a:prstDash val="solid"/>
-                      <a:round/>
-                      <a:headEnd type="none" w="sm" len="sm"/>
-                      <a:tailEnd type="none" w="sm" len="sm"/>
-                    </a:lnL>
-                    <a:lnR w="9525" cap="flat" cmpd="sng">
-                      <a:solidFill>
-                        <a:srgbClr val="CCCCCC"/>
-                      </a:solidFill>
-                      <a:prstDash val="solid"/>
-                      <a:round/>
-                      <a:headEnd type="none" w="sm" len="sm"/>
-                      <a:tailEnd type="none" w="sm" len="sm"/>
-                    </a:lnR>
-                    <a:lnT w="9525" cap="flat" cmpd="sng">
-                      <a:solidFill>
-                        <a:srgbClr val="CCCCCC"/>
-                      </a:solidFill>
-                      <a:prstDash val="solid"/>
-                      <a:round/>
-                      <a:headEnd type="none" w="sm" len="sm"/>
-                      <a:tailEnd type="none" w="sm" len="sm"/>
-                    </a:lnT>
-                    <a:lnB w="9525" cap="flat" cmpd="sng">
-                      <a:solidFill>
-                        <a:srgbClr val="CCCCCC"/>
-                      </a:solidFill>
-                      <a:prstDash val="solid"/>
-                      <a:round/>
-                      <a:headEnd type="none" w="sm" len="sm"/>
-                      <a:tailEnd type="none" w="sm" len="sm"/>
-                    </a:lnB>
-                    <a:solidFill>
-                      <a:srgbClr val="C6EFCE"/>
-                    </a:solidFill>
-                  </a:tcPr>
-                </a:tc>
-                <a:tc>
-                  <a:txBody>
-                    <a:bodyPr/>
-                    <a:lstStyle/>
-                    <a:p>
-                      <a:pPr marL="0" lvl="0" indent="0" algn="r" rtl="0">
-                        <a:lnSpc>
-                          <a:spcPct val="115000"/>
-                        </a:lnSpc>
-                        <a:spcBef>
-                          <a:spcPts val="0"/>
-                        </a:spcBef>
-                        <a:spcAft>
-                          <a:spcPts val="0"/>
-                        </a:spcAft>
-                        <a:buNone/>
-                      </a:pPr>
-                      <a:r>
-                        <a:rPr lang="es-CL" sz="1000"/>
-                        <a:t>2</a:t>
-                      </a:r>
-                      <a:endParaRPr sz="1000"/>
-                    </a:p>
-                  </a:txBody>
-                  <a:tcPr marL="28575" marR="28575" marT="91425" marB="91425">
-                    <a:lnL w="9525" cap="flat" cmpd="sng">
-                      <a:solidFill>
-                        <a:srgbClr val="CCCCCC"/>
-                      </a:solidFill>
-                      <a:prstDash val="solid"/>
-                      <a:round/>
-                      <a:headEnd type="none" w="sm" len="sm"/>
-                      <a:tailEnd type="none" w="sm" len="sm"/>
-                    </a:lnL>
-                    <a:lnR w="9525" cap="flat" cmpd="sng">
-                      <a:solidFill>
-                        <a:srgbClr val="CCCCCC"/>
-                      </a:solidFill>
-                      <a:prstDash val="solid"/>
-                      <a:round/>
-                      <a:headEnd type="none" w="sm" len="sm"/>
-                      <a:tailEnd type="none" w="sm" len="sm"/>
-                    </a:lnR>
-                    <a:lnT w="9525" cap="flat" cmpd="sng">
-                      <a:solidFill>
-                        <a:srgbClr val="CCCCCC"/>
-                      </a:solidFill>
-                      <a:prstDash val="solid"/>
-                      <a:round/>
-                      <a:headEnd type="none" w="sm" len="sm"/>
-                      <a:tailEnd type="none" w="sm" len="sm"/>
-                    </a:lnT>
-                    <a:lnB w="9525" cap="flat" cmpd="sng">
-                      <a:solidFill>
-                        <a:srgbClr val="CCCCCC"/>
-                      </a:solidFill>
-                      <a:prstDash val="solid"/>
-                      <a:round/>
-                      <a:headEnd type="none" w="sm" len="sm"/>
-                      <a:tailEnd type="none" w="sm" len="sm"/>
-                    </a:lnB>
-                  </a:tcPr>
-                </a:tc>
-                <a:tc>
-                  <a:txBody>
-                    <a:bodyPr/>
-                    <a:lstStyle/>
-                    <a:p>
-                      <a:pPr marL="0" lvl="0" indent="0" algn="l" rtl="0">
-                        <a:lnSpc>
-                          <a:spcPct val="115000"/>
-                        </a:lnSpc>
-                        <a:spcBef>
-                          <a:spcPts val="0"/>
-                        </a:spcBef>
-                        <a:spcAft>
-                          <a:spcPts val="0"/>
-                        </a:spcAft>
-                        <a:buNone/>
-                      </a:pPr>
-                      <a:r>
-                        <a:rPr lang="es-CL" sz="1000"/>
-                        <a:t>Sprint 5</a:t>
-                      </a:r>
-                      <a:endParaRPr sz="1000"/>
-                    </a:p>
-                  </a:txBody>
-                  <a:tcPr marL="28575" marR="28575" marT="91425" marB="91425">
-                    <a:lnL w="9525" cap="flat" cmpd="sng">
-                      <a:solidFill>
-                        <a:srgbClr val="CCCCCC"/>
-                      </a:solidFill>
-                      <a:prstDash val="solid"/>
-                      <a:round/>
-                      <a:headEnd type="none" w="sm" len="sm"/>
-                      <a:tailEnd type="none" w="sm" len="sm"/>
-                    </a:lnL>
-                    <a:lnR w="9525" cap="flat" cmpd="sng">
-                      <a:solidFill>
-                        <a:srgbClr val="CCCCCC"/>
-                      </a:solidFill>
-                      <a:prstDash val="solid"/>
-                      <a:round/>
-                      <a:headEnd type="none" w="sm" len="sm"/>
-                      <a:tailEnd type="none" w="sm" len="sm"/>
-                    </a:lnR>
-                    <a:lnT w="9525" cap="flat" cmpd="sng">
-                      <a:solidFill>
-                        <a:srgbClr val="CCCCCC"/>
-                      </a:solidFill>
-                      <a:prstDash val="solid"/>
-                      <a:round/>
-                      <a:headEnd type="none" w="sm" len="sm"/>
-                      <a:tailEnd type="none" w="sm" len="sm"/>
-                    </a:lnT>
-                    <a:lnB w="9525" cap="flat" cmpd="sng">
-                      <a:solidFill>
-                        <a:srgbClr val="CCCCCC"/>
-                      </a:solidFill>
-                      <a:prstDash val="solid"/>
-                      <a:round/>
-                      <a:headEnd type="none" w="sm" len="sm"/>
-                      <a:tailEnd type="none" w="sm" len="sm"/>
-                    </a:lnB>
-                  </a:tcPr>
-                </a:tc>
-                <a:tc>
-                  <a:txBody>
-                    <a:bodyPr/>
-                    <a:lstStyle/>
-                    <a:p>
-                      <a:pPr marL="0" lvl="0" indent="0" algn="l" rtl="0">
-                        <a:lnSpc>
-                          <a:spcPct val="115000"/>
-                        </a:lnSpc>
-                        <a:spcBef>
-                          <a:spcPts val="0"/>
-                        </a:spcBef>
-                        <a:spcAft>
-                          <a:spcPts val="0"/>
-                        </a:spcAft>
-                        <a:buNone/>
-                      </a:pPr>
-                      <a:r>
-                        <a:rPr lang="es-CL" sz="1000"/>
-                        <a:t>Pendiente</a:t>
-                      </a:r>
-                      <a:endParaRPr sz="1000"/>
-                    </a:p>
-                  </a:txBody>
-                  <a:tcPr marL="28575" marR="28575" marT="91425" marB="91425">
-                    <a:lnL w="9525" cap="flat" cmpd="sng">
-                      <a:solidFill>
-                        <a:srgbClr val="CCCCCC"/>
-                      </a:solidFill>
-                      <a:prstDash val="solid"/>
-                      <a:round/>
-                      <a:headEnd type="none" w="sm" len="sm"/>
-                      <a:tailEnd type="none" w="sm" len="sm"/>
-                    </a:lnL>
-                    <a:lnR w="9525" cap="flat" cmpd="sng">
-                      <a:solidFill>
-                        <a:srgbClr val="CCCCCC"/>
-                      </a:solidFill>
-                      <a:prstDash val="solid"/>
-                      <a:round/>
-                      <a:headEnd type="none" w="sm" len="sm"/>
-                      <a:tailEnd type="none" w="sm" len="sm"/>
-                    </a:lnR>
-                    <a:lnT w="9525" cap="flat" cmpd="sng">
-                      <a:solidFill>
-                        <a:srgbClr val="CCCCCC"/>
-                      </a:solidFill>
-                      <a:prstDash val="solid"/>
-                      <a:round/>
-                      <a:headEnd type="none" w="sm" len="sm"/>
-                      <a:tailEnd type="none" w="sm" len="sm"/>
-                    </a:lnT>
-                    <a:lnB w="9525" cap="flat" cmpd="sng">
-                      <a:solidFill>
-                        <a:srgbClr val="CCCCCC"/>
-                      </a:solidFill>
-                      <a:prstDash val="solid"/>
-                      <a:round/>
-                      <a:headEnd type="none" w="sm" len="sm"/>
-                      <a:tailEnd type="none" w="sm" len="sm"/>
-                    </a:lnB>
-                  </a:tcPr>
-                </a:tc>
-                <a:extLst>
-                  <a:ext uri="{0D108BD9-81ED-4DB2-BD59-A6C34878D82A}">
-                    <a16:rowId xmlns:a16="http://schemas.microsoft.com/office/drawing/2014/main" val="10003"/>
-                  </a:ext>
-                </a:extLst>
-              </a:tr>
-            </a:tbl>
-          </a:graphicData>
-        </a:graphic>
-      </p:graphicFrame>
+        </p:nvPicPr>
+        <p:blipFill>
+          <a:blip r:embed="rId4"/>
+          <a:stretch>
+            <a:fillRect/>
+          </a:stretch>
+        </p:blipFill>
+        <p:spPr>
+          <a:xfrm>
+            <a:off x="0" y="1590675"/>
+            <a:ext cx="12192000" cy="3676650"/>
+          </a:xfrm>
+          <a:prstGeom prst="rect">
+            <a:avLst/>
+          </a:prstGeom>
+        </p:spPr>
+      </p:pic>
     </p:spTree>
   </p:cSld>
   <p:clrMapOvr>

</xml_diff>